<commit_message>
changes to ppt and report
</commit_message>
<xml_diff>
--- a/presentation/NORP_Final_Presentation.pptx
+++ b/presentation/NORP_Final_Presentation.pptx
@@ -4,23 +4,26 @@
   <p:sldMasterIdLst>
     <p:sldMasterId id="2147483648" r:id="rId1"/>
   </p:sldMasterIdLst>
+  <p:notesMasterIdLst>
+    <p:notesMasterId r:id="rId16"/>
+  </p:notesMasterIdLst>
   <p:sldIdLst>
-    <p:sldId id="256" r:id="rId7"/>
-    <p:sldId id="257" r:id="rId8"/>
-    <p:sldId id="258" r:id="rId9"/>
-    <p:sldId id="259" r:id="rId10"/>
-    <p:sldId id="260" r:id="rId11"/>
-    <p:sldId id="261" r:id="rId12"/>
-    <p:sldId id="262" r:id="rId13"/>
-    <p:sldId id="263" r:id="rId14"/>
-    <p:sldId id="264" r:id="rId15"/>
-    <p:sldId id="265" r:id="rId16"/>
-    <p:sldId id="266" r:id="rId17"/>
-    <p:sldId id="267" r:id="rId18"/>
-    <p:sldId id="268" r:id="rId19"/>
-    <p:sldId id="269" r:id="rId20"/>
+    <p:sldId id="256" r:id="rId2"/>
+    <p:sldId id="257" r:id="rId3"/>
+    <p:sldId id="258" r:id="rId4"/>
+    <p:sldId id="259" r:id="rId5"/>
+    <p:sldId id="260" r:id="rId6"/>
+    <p:sldId id="261" r:id="rId7"/>
+    <p:sldId id="262" r:id="rId8"/>
+    <p:sldId id="263" r:id="rId9"/>
+    <p:sldId id="264" r:id="rId10"/>
+    <p:sldId id="265" r:id="rId11"/>
+    <p:sldId id="266" r:id="rId12"/>
+    <p:sldId id="267" r:id="rId13"/>
+    <p:sldId id="268" r:id="rId14"/>
+    <p:sldId id="269" r:id="rId15"/>
   </p:sldIdLst>
-  <p:sldSz cx="12191695" cy="6858000" type="screen4x3"/>
+  <p:sldSz cx="12192000" cy="6858000"/>
   <p:notesSz cx="6858000" cy="9144000"/>
   <p:defaultTextStyle>
     <a:defPPr>
@@ -117,7 +120,456 @@
       </a:defRPr>
     </a:lvl9pPr>
   </p:defaultTextStyle>
+  <p:extLst>
+    <p:ext uri="{EFAFB233-063F-42B5-8137-9DF3F51BA10A}">
+      <p15:sldGuideLst xmlns:p15="http://schemas.microsoft.com/office/powerpoint/2012/main">
+        <p15:guide id="1" orient="horz" pos="2160">
+          <p15:clr>
+            <a:srgbClr val="A4A3A4"/>
+          </p15:clr>
+        </p15:guide>
+        <p15:guide id="2" pos="2880">
+          <p15:clr>
+            <a:srgbClr val="A4A3A4"/>
+          </p15:clr>
+        </p15:guide>
+      </p15:sldGuideLst>
+    </p:ext>
+  </p:extLst>
 </p:presentation>
+</file>
+
+<file path=ppt/notesMasters/notesMaster1.xml><?xml version="1.0" encoding="utf-8"?>
+<p:notesMaster xmlns:a="http://schemas.openxmlformats.org/drawingml/2006/main" xmlns:r="http://schemas.openxmlformats.org/officeDocument/2006/relationships" xmlns:p="http://schemas.openxmlformats.org/presentationml/2006/main">
+  <p:cSld>
+    <p:bg>
+      <p:bgRef idx="1001">
+        <a:schemeClr val="bg1"/>
+      </p:bgRef>
+    </p:bg>
+    <p:spTree>
+      <p:nvGrpSpPr>
+        <p:cNvPr id="1" name=""/>
+        <p:cNvGrpSpPr/>
+        <p:nvPr/>
+      </p:nvGrpSpPr>
+      <p:grpSpPr>
+        <a:xfrm>
+          <a:off x="0" y="0"/>
+          <a:ext cx="0" cy="0"/>
+          <a:chOff x="0" y="0"/>
+          <a:chExt cx="0" cy="0"/>
+        </a:xfrm>
+      </p:grpSpPr>
+      <p:sp>
+        <p:nvSpPr>
+          <p:cNvPr id="2" name="Header Placeholder 1"/>
+          <p:cNvSpPr>
+            <a:spLocks noGrp="1"/>
+          </p:cNvSpPr>
+          <p:nvPr>
+            <p:ph type="hdr" sz="quarter"/>
+          </p:nvPr>
+        </p:nvSpPr>
+        <p:spPr>
+          <a:xfrm>
+            <a:off x="0" y="0"/>
+            <a:ext cx="2971800" cy="458788"/>
+          </a:xfrm>
+          <a:prstGeom prst="rect">
+            <a:avLst/>
+          </a:prstGeom>
+        </p:spPr>
+        <p:txBody>
+          <a:bodyPr vert="horz" lIns="91440" tIns="45720" rIns="91440" bIns="45720" rtlCol="0"/>
+          <a:lstStyle>
+            <a:lvl1pPr algn="l">
+              <a:defRPr sz="1200"/>
+            </a:lvl1pPr>
+          </a:lstStyle>
+          <a:p>
+            <a:endParaRPr lang="en-US"/>
+          </a:p>
+        </p:txBody>
+      </p:sp>
+      <p:sp>
+        <p:nvSpPr>
+          <p:cNvPr id="3" name="Date Placeholder 2"/>
+          <p:cNvSpPr>
+            <a:spLocks noGrp="1"/>
+          </p:cNvSpPr>
+          <p:nvPr>
+            <p:ph type="dt" idx="1"/>
+          </p:nvPr>
+        </p:nvSpPr>
+        <p:spPr>
+          <a:xfrm>
+            <a:off x="3884613" y="0"/>
+            <a:ext cx="2971800" cy="458788"/>
+          </a:xfrm>
+          <a:prstGeom prst="rect">
+            <a:avLst/>
+          </a:prstGeom>
+        </p:spPr>
+        <p:txBody>
+          <a:bodyPr vert="horz" lIns="91440" tIns="45720" rIns="91440" bIns="45720" rtlCol="0"/>
+          <a:lstStyle>
+            <a:lvl1pPr algn="r">
+              <a:defRPr sz="1200"/>
+            </a:lvl1pPr>
+          </a:lstStyle>
+          <a:p>
+            <a:fld id="{EAF10578-759C-5945-ACA3-D4FDE0DEFB2D}" type="datetimeFigureOut">
+              <a:rPr lang="en-US" smtClean="0"/>
+              <a:t>7/27/26</a:t>
+            </a:fld>
+            <a:endParaRPr lang="en-US"/>
+          </a:p>
+        </p:txBody>
+      </p:sp>
+      <p:sp>
+        <p:nvSpPr>
+          <p:cNvPr id="4" name="Slide Image Placeholder 3"/>
+          <p:cNvSpPr>
+            <a:spLocks noGrp="1" noRot="1" noChangeAspect="1"/>
+          </p:cNvSpPr>
+          <p:nvPr>
+            <p:ph type="sldImg" idx="2"/>
+          </p:nvPr>
+        </p:nvSpPr>
+        <p:spPr>
+          <a:xfrm>
+            <a:off x="685800" y="1143000"/>
+            <a:ext cx="5486400" cy="3086100"/>
+          </a:xfrm>
+          <a:prstGeom prst="rect">
+            <a:avLst/>
+          </a:prstGeom>
+          <a:noFill/>
+          <a:ln w="12700">
+            <a:solidFill>
+              <a:prstClr val="black"/>
+            </a:solidFill>
+          </a:ln>
+        </p:spPr>
+        <p:txBody>
+          <a:bodyPr vert="horz" lIns="91440" tIns="45720" rIns="91440" bIns="45720" rtlCol="0" anchor="ctr"/>
+          <a:lstStyle/>
+          <a:p>
+            <a:endParaRPr lang="en-US"/>
+          </a:p>
+        </p:txBody>
+      </p:sp>
+      <p:sp>
+        <p:nvSpPr>
+          <p:cNvPr id="5" name="Notes Placeholder 4"/>
+          <p:cNvSpPr>
+            <a:spLocks noGrp="1"/>
+          </p:cNvSpPr>
+          <p:nvPr>
+            <p:ph type="body" sz="quarter" idx="3"/>
+          </p:nvPr>
+        </p:nvSpPr>
+        <p:spPr>
+          <a:xfrm>
+            <a:off x="685800" y="4400550"/>
+            <a:ext cx="5486400" cy="3600450"/>
+          </a:xfrm>
+          <a:prstGeom prst="rect">
+            <a:avLst/>
+          </a:prstGeom>
+        </p:spPr>
+        <p:txBody>
+          <a:bodyPr vert="horz" lIns="91440" tIns="45720" rIns="91440" bIns="45720" rtlCol="0"/>
+          <a:lstStyle/>
+          <a:p>
+            <a:pPr lvl="0"/>
+            <a:r>
+              <a:rPr lang="en-US"/>
+              <a:t>Click to edit Master text styles</a:t>
+            </a:r>
+          </a:p>
+          <a:p>
+            <a:pPr lvl="1"/>
+            <a:r>
+              <a:rPr lang="en-US"/>
+              <a:t>Second level</a:t>
+            </a:r>
+          </a:p>
+          <a:p>
+            <a:pPr lvl="2"/>
+            <a:r>
+              <a:rPr lang="en-US"/>
+              <a:t>Third level</a:t>
+            </a:r>
+          </a:p>
+          <a:p>
+            <a:pPr lvl="3"/>
+            <a:r>
+              <a:rPr lang="en-US"/>
+              <a:t>Fourth level</a:t>
+            </a:r>
+          </a:p>
+          <a:p>
+            <a:pPr lvl="4"/>
+            <a:r>
+              <a:rPr lang="en-US"/>
+              <a:t>Fifth level</a:t>
+            </a:r>
+          </a:p>
+        </p:txBody>
+      </p:sp>
+      <p:sp>
+        <p:nvSpPr>
+          <p:cNvPr id="6" name="Footer Placeholder 5"/>
+          <p:cNvSpPr>
+            <a:spLocks noGrp="1"/>
+          </p:cNvSpPr>
+          <p:nvPr>
+            <p:ph type="ftr" sz="quarter" idx="4"/>
+          </p:nvPr>
+        </p:nvSpPr>
+        <p:spPr>
+          <a:xfrm>
+            <a:off x="0" y="8685213"/>
+            <a:ext cx="2971800" cy="458787"/>
+          </a:xfrm>
+          <a:prstGeom prst="rect">
+            <a:avLst/>
+          </a:prstGeom>
+        </p:spPr>
+        <p:txBody>
+          <a:bodyPr vert="horz" lIns="91440" tIns="45720" rIns="91440" bIns="45720" rtlCol="0" anchor="b"/>
+          <a:lstStyle>
+            <a:lvl1pPr algn="l">
+              <a:defRPr sz="1200"/>
+            </a:lvl1pPr>
+          </a:lstStyle>
+          <a:p>
+            <a:endParaRPr lang="en-US"/>
+          </a:p>
+        </p:txBody>
+      </p:sp>
+      <p:sp>
+        <p:nvSpPr>
+          <p:cNvPr id="7" name="Slide Number Placeholder 6"/>
+          <p:cNvSpPr>
+            <a:spLocks noGrp="1"/>
+          </p:cNvSpPr>
+          <p:nvPr>
+            <p:ph type="sldNum" sz="quarter" idx="5"/>
+          </p:nvPr>
+        </p:nvSpPr>
+        <p:spPr>
+          <a:xfrm>
+            <a:off x="3884613" y="8685213"/>
+            <a:ext cx="2971800" cy="458787"/>
+          </a:xfrm>
+          <a:prstGeom prst="rect">
+            <a:avLst/>
+          </a:prstGeom>
+        </p:spPr>
+        <p:txBody>
+          <a:bodyPr vert="horz" lIns="91440" tIns="45720" rIns="91440" bIns="45720" rtlCol="0" anchor="b"/>
+          <a:lstStyle>
+            <a:lvl1pPr algn="r">
+              <a:defRPr sz="1200"/>
+            </a:lvl1pPr>
+          </a:lstStyle>
+          <a:p>
+            <a:fld id="{59F0FBF3-A5DA-B74C-91D9-61F5C7B120A0}" type="slidenum">
+              <a:rPr lang="en-US" smtClean="0"/>
+              <a:t>‹#›</a:t>
+            </a:fld>
+            <a:endParaRPr lang="en-US"/>
+          </a:p>
+        </p:txBody>
+      </p:sp>
+    </p:spTree>
+    <p:extLst>
+      <p:ext uri="{BB962C8B-B14F-4D97-AF65-F5344CB8AC3E}">
+        <p14:creationId xmlns:p14="http://schemas.microsoft.com/office/powerpoint/2010/main" val="1047462633"/>
+      </p:ext>
+    </p:extLst>
+  </p:cSld>
+  <p:clrMap bg1="lt1" tx1="dk1" bg2="lt2" tx2="dk2" accent1="accent1" accent2="accent2" accent3="accent3" accent4="accent4" accent5="accent5" accent6="accent6" hlink="hlink" folHlink="folHlink"/>
+  <p:notesStyle>
+    <a:lvl1pPr marL="0" algn="l" defTabSz="914400" rtl="0" eaLnBrk="1" latinLnBrk="0" hangingPunct="1">
+      <a:defRPr sz="1200" kern="1200">
+        <a:solidFill>
+          <a:schemeClr val="tx1"/>
+        </a:solidFill>
+        <a:latin typeface="+mn-lt"/>
+        <a:ea typeface="+mn-ea"/>
+        <a:cs typeface="+mn-cs"/>
+      </a:defRPr>
+    </a:lvl1pPr>
+    <a:lvl2pPr marL="457200" algn="l" defTabSz="914400" rtl="0" eaLnBrk="1" latinLnBrk="0" hangingPunct="1">
+      <a:defRPr sz="1200" kern="1200">
+        <a:solidFill>
+          <a:schemeClr val="tx1"/>
+        </a:solidFill>
+        <a:latin typeface="+mn-lt"/>
+        <a:ea typeface="+mn-ea"/>
+        <a:cs typeface="+mn-cs"/>
+      </a:defRPr>
+    </a:lvl2pPr>
+    <a:lvl3pPr marL="914400" algn="l" defTabSz="914400" rtl="0" eaLnBrk="1" latinLnBrk="0" hangingPunct="1">
+      <a:defRPr sz="1200" kern="1200">
+        <a:solidFill>
+          <a:schemeClr val="tx1"/>
+        </a:solidFill>
+        <a:latin typeface="+mn-lt"/>
+        <a:ea typeface="+mn-ea"/>
+        <a:cs typeface="+mn-cs"/>
+      </a:defRPr>
+    </a:lvl3pPr>
+    <a:lvl4pPr marL="1371600" algn="l" defTabSz="914400" rtl="0" eaLnBrk="1" latinLnBrk="0" hangingPunct="1">
+      <a:defRPr sz="1200" kern="1200">
+        <a:solidFill>
+          <a:schemeClr val="tx1"/>
+        </a:solidFill>
+        <a:latin typeface="+mn-lt"/>
+        <a:ea typeface="+mn-ea"/>
+        <a:cs typeface="+mn-cs"/>
+      </a:defRPr>
+    </a:lvl4pPr>
+    <a:lvl5pPr marL="1828800" algn="l" defTabSz="914400" rtl="0" eaLnBrk="1" latinLnBrk="0" hangingPunct="1">
+      <a:defRPr sz="1200" kern="1200">
+        <a:solidFill>
+          <a:schemeClr val="tx1"/>
+        </a:solidFill>
+        <a:latin typeface="+mn-lt"/>
+        <a:ea typeface="+mn-ea"/>
+        <a:cs typeface="+mn-cs"/>
+      </a:defRPr>
+    </a:lvl5pPr>
+    <a:lvl6pPr marL="2286000" algn="l" defTabSz="914400" rtl="0" eaLnBrk="1" latinLnBrk="0" hangingPunct="1">
+      <a:defRPr sz="1200" kern="1200">
+        <a:solidFill>
+          <a:schemeClr val="tx1"/>
+        </a:solidFill>
+        <a:latin typeface="+mn-lt"/>
+        <a:ea typeface="+mn-ea"/>
+        <a:cs typeface="+mn-cs"/>
+      </a:defRPr>
+    </a:lvl6pPr>
+    <a:lvl7pPr marL="2743200" algn="l" defTabSz="914400" rtl="0" eaLnBrk="1" latinLnBrk="0" hangingPunct="1">
+      <a:defRPr sz="1200" kern="1200">
+        <a:solidFill>
+          <a:schemeClr val="tx1"/>
+        </a:solidFill>
+        <a:latin typeface="+mn-lt"/>
+        <a:ea typeface="+mn-ea"/>
+        <a:cs typeface="+mn-cs"/>
+      </a:defRPr>
+    </a:lvl7pPr>
+    <a:lvl8pPr marL="3200400" algn="l" defTabSz="914400" rtl="0" eaLnBrk="1" latinLnBrk="0" hangingPunct="1">
+      <a:defRPr sz="1200" kern="1200">
+        <a:solidFill>
+          <a:schemeClr val="tx1"/>
+        </a:solidFill>
+        <a:latin typeface="+mn-lt"/>
+        <a:ea typeface="+mn-ea"/>
+        <a:cs typeface="+mn-cs"/>
+      </a:defRPr>
+    </a:lvl8pPr>
+    <a:lvl9pPr marL="3657600" algn="l" defTabSz="914400" rtl="0" eaLnBrk="1" latinLnBrk="0" hangingPunct="1">
+      <a:defRPr sz="1200" kern="1200">
+        <a:solidFill>
+          <a:schemeClr val="tx1"/>
+        </a:solidFill>
+        <a:latin typeface="+mn-lt"/>
+        <a:ea typeface="+mn-ea"/>
+        <a:cs typeface="+mn-cs"/>
+      </a:defRPr>
+    </a:lvl9pPr>
+  </p:notesStyle>
+</p:notesMaster>
+</file>
+
+<file path=ppt/notesSlides/notesSlide1.xml><?xml version="1.0" encoding="utf-8"?>
+<p:notes xmlns:a="http://schemas.openxmlformats.org/drawingml/2006/main" xmlns:r="http://schemas.openxmlformats.org/officeDocument/2006/relationships" xmlns:p="http://schemas.openxmlformats.org/presentationml/2006/main">
+  <p:cSld>
+    <p:spTree>
+      <p:nvGrpSpPr>
+        <p:cNvPr id="1" name=""/>
+        <p:cNvGrpSpPr/>
+        <p:nvPr/>
+      </p:nvGrpSpPr>
+      <p:grpSpPr>
+        <a:xfrm>
+          <a:off x="0" y="0"/>
+          <a:ext cx="0" cy="0"/>
+          <a:chOff x="0" y="0"/>
+          <a:chExt cx="0" cy="0"/>
+        </a:xfrm>
+      </p:grpSpPr>
+      <p:sp>
+        <p:nvSpPr>
+          <p:cNvPr id="2" name="Slide Image Placeholder 1"/>
+          <p:cNvSpPr>
+            <a:spLocks noGrp="1" noRot="1" noChangeAspect="1"/>
+          </p:cNvSpPr>
+          <p:nvPr>
+            <p:ph type="sldImg"/>
+          </p:nvPr>
+        </p:nvSpPr>
+        <p:spPr/>
+      </p:sp>
+      <p:sp>
+        <p:nvSpPr>
+          <p:cNvPr id="3" name="Notes Placeholder 2"/>
+          <p:cNvSpPr>
+            <a:spLocks noGrp="1"/>
+          </p:cNvSpPr>
+          <p:nvPr>
+            <p:ph type="body" idx="1"/>
+          </p:nvPr>
+        </p:nvSpPr>
+        <p:spPr/>
+        <p:txBody>
+          <a:bodyPr/>
+          <a:lstStyle/>
+          <a:p>
+            <a:endParaRPr lang="en-US" dirty="0"/>
+          </a:p>
+        </p:txBody>
+      </p:sp>
+      <p:sp>
+        <p:nvSpPr>
+          <p:cNvPr id="4" name="Slide Number Placeholder 3"/>
+          <p:cNvSpPr>
+            <a:spLocks noGrp="1"/>
+          </p:cNvSpPr>
+          <p:nvPr>
+            <p:ph type="sldNum" sz="quarter" idx="5"/>
+          </p:nvPr>
+        </p:nvSpPr>
+        <p:spPr/>
+        <p:txBody>
+          <a:bodyPr/>
+          <a:lstStyle/>
+          <a:p>
+            <a:fld id="{59F0FBF3-A5DA-B74C-91D9-61F5C7B120A0}" type="slidenum">
+              <a:rPr lang="en-US" smtClean="0"/>
+              <a:t>3</a:t>
+            </a:fld>
+            <a:endParaRPr lang="en-US"/>
+          </a:p>
+        </p:txBody>
+      </p:sp>
+    </p:spTree>
+    <p:extLst>
+      <p:ext uri="{BB962C8B-B14F-4D97-AF65-F5344CB8AC3E}">
+        <p14:creationId xmlns:p14="http://schemas.microsoft.com/office/powerpoint/2010/main" val="2679008329"/>
+      </p:ext>
+    </p:extLst>
+  </p:cSld>
+  <p:clrMapOvr>
+    <a:masterClrMapping/>
+  </p:clrMapOvr>
+</p:notes>
 </file>
 
 <file path=ppt/slideLayouts/slideLayout1.xml><?xml version="1.0" encoding="utf-8"?>
@@ -158,10 +610,9 @@
           <a:lstStyle/>
           <a:p>
             <a:r>
-              <a:rPr lang="en-US" smtClean="0"/>
+              <a:rPr lang="en-US"/>
               <a:t>Click to edit Master title style</a:t>
             </a:r>
-            <a:endParaRPr lang="en-US"/>
           </a:p>
         </p:txBody>
       </p:sp>
@@ -277,10 +728,9 @@
           </a:lstStyle>
           <a:p>
             <a:r>
-              <a:rPr lang="en-US" smtClean="0"/>
+              <a:rPr lang="en-US"/>
               <a:t>Click to edit Master subtitle style</a:t>
             </a:r>
-            <a:endParaRPr lang="en-US"/>
           </a:p>
         </p:txBody>
       </p:sp>
@@ -301,7 +751,7 @@
           <a:p>
             <a:fld id="{5BCAD085-E8A6-8845-BD4E-CB4CCA059FC4}" type="datetimeFigureOut">
               <a:rPr lang="en-US" smtClean="0"/>
-              <a:t>1/27/13</a:t>
+              <a:t>7/27/26</a:t>
             </a:fld>
             <a:endParaRPr lang="en-US"/>
           </a:p>
@@ -395,10 +845,9 @@
           <a:lstStyle/>
           <a:p>
             <a:r>
-              <a:rPr lang="en-US" smtClean="0"/>
+              <a:rPr lang="en-US"/>
               <a:t>Click to edit Master title style</a:t>
             </a:r>
-            <a:endParaRPr lang="en-US"/>
           </a:p>
         </p:txBody>
       </p:sp>
@@ -419,38 +868,37 @@
           <a:p>
             <a:pPr lvl="0"/>
             <a:r>
-              <a:rPr lang="en-US" smtClean="0"/>
+              <a:rPr lang="en-US"/>
               <a:t>Click to edit Master text styles</a:t>
             </a:r>
           </a:p>
           <a:p>
             <a:pPr lvl="1"/>
             <a:r>
-              <a:rPr lang="en-US" smtClean="0"/>
+              <a:rPr lang="en-US"/>
               <a:t>Second level</a:t>
             </a:r>
           </a:p>
           <a:p>
             <a:pPr lvl="2"/>
             <a:r>
-              <a:rPr lang="en-US" smtClean="0"/>
+              <a:rPr lang="en-US"/>
               <a:t>Third level</a:t>
             </a:r>
           </a:p>
           <a:p>
             <a:pPr lvl="3"/>
             <a:r>
-              <a:rPr lang="en-US" smtClean="0"/>
+              <a:rPr lang="en-US"/>
               <a:t>Fourth level</a:t>
             </a:r>
           </a:p>
           <a:p>
             <a:pPr lvl="4"/>
             <a:r>
-              <a:rPr lang="en-US" smtClean="0"/>
+              <a:rPr lang="en-US"/>
               <a:t>Fifth level</a:t>
             </a:r>
-            <a:endParaRPr lang="en-US"/>
           </a:p>
         </p:txBody>
       </p:sp>
@@ -471,7 +919,7 @@
           <a:p>
             <a:fld id="{5BCAD085-E8A6-8845-BD4E-CB4CCA059FC4}" type="datetimeFigureOut">
               <a:rPr lang="en-US" smtClean="0"/>
-              <a:t>1/27/13</a:t>
+              <a:t>7/27/26</a:t>
             </a:fld>
             <a:endParaRPr lang="en-US"/>
           </a:p>
@@ -570,10 +1018,9 @@
           <a:lstStyle/>
           <a:p>
             <a:r>
-              <a:rPr lang="en-US" smtClean="0"/>
+              <a:rPr lang="en-US"/>
               <a:t>Click to edit Master title style</a:t>
             </a:r>
-            <a:endParaRPr lang="en-US"/>
           </a:p>
         </p:txBody>
       </p:sp>
@@ -599,38 +1046,37 @@
           <a:p>
             <a:pPr lvl="0"/>
             <a:r>
-              <a:rPr lang="en-US" smtClean="0"/>
+              <a:rPr lang="en-US"/>
               <a:t>Click to edit Master text styles</a:t>
             </a:r>
           </a:p>
           <a:p>
             <a:pPr lvl="1"/>
             <a:r>
-              <a:rPr lang="en-US" smtClean="0"/>
+              <a:rPr lang="en-US"/>
               <a:t>Second level</a:t>
             </a:r>
           </a:p>
           <a:p>
             <a:pPr lvl="2"/>
             <a:r>
-              <a:rPr lang="en-US" smtClean="0"/>
+              <a:rPr lang="en-US"/>
               <a:t>Third level</a:t>
             </a:r>
           </a:p>
           <a:p>
             <a:pPr lvl="3"/>
             <a:r>
-              <a:rPr lang="en-US" smtClean="0"/>
+              <a:rPr lang="en-US"/>
               <a:t>Fourth level</a:t>
             </a:r>
           </a:p>
           <a:p>
             <a:pPr lvl="4"/>
             <a:r>
-              <a:rPr lang="en-US" smtClean="0"/>
+              <a:rPr lang="en-US"/>
               <a:t>Fifth level</a:t>
             </a:r>
-            <a:endParaRPr lang="en-US"/>
           </a:p>
         </p:txBody>
       </p:sp>
@@ -651,7 +1097,7 @@
           <a:p>
             <a:fld id="{5BCAD085-E8A6-8845-BD4E-CB4CCA059FC4}" type="datetimeFigureOut">
               <a:rPr lang="en-US" smtClean="0"/>
-              <a:t>1/27/13</a:t>
+              <a:t>7/27/26</a:t>
             </a:fld>
             <a:endParaRPr lang="en-US"/>
           </a:p>
@@ -745,10 +1191,9 @@
           <a:lstStyle/>
           <a:p>
             <a:r>
-              <a:rPr lang="en-US" smtClean="0"/>
+              <a:rPr lang="en-US"/>
               <a:t>Click to edit Master title style</a:t>
             </a:r>
-            <a:endParaRPr lang="en-US"/>
           </a:p>
         </p:txBody>
       </p:sp>
@@ -769,38 +1214,37 @@
           <a:p>
             <a:pPr lvl="0"/>
             <a:r>
-              <a:rPr lang="en-US" smtClean="0"/>
+              <a:rPr lang="en-US"/>
               <a:t>Click to edit Master text styles</a:t>
             </a:r>
           </a:p>
           <a:p>
             <a:pPr lvl="1"/>
             <a:r>
-              <a:rPr lang="en-US" smtClean="0"/>
+              <a:rPr lang="en-US"/>
               <a:t>Second level</a:t>
             </a:r>
           </a:p>
           <a:p>
             <a:pPr lvl="2"/>
             <a:r>
-              <a:rPr lang="en-US" smtClean="0"/>
+              <a:rPr lang="en-US"/>
               <a:t>Third level</a:t>
             </a:r>
           </a:p>
           <a:p>
             <a:pPr lvl="3"/>
             <a:r>
-              <a:rPr lang="en-US" smtClean="0"/>
+              <a:rPr lang="en-US"/>
               <a:t>Fourth level</a:t>
             </a:r>
           </a:p>
           <a:p>
             <a:pPr lvl="4"/>
             <a:r>
-              <a:rPr lang="en-US" smtClean="0"/>
+              <a:rPr lang="en-US"/>
               <a:t>Fifth level</a:t>
             </a:r>
-            <a:endParaRPr lang="en-US"/>
           </a:p>
         </p:txBody>
       </p:sp>
@@ -821,7 +1265,7 @@
           <a:p>
             <a:fld id="{5BCAD085-E8A6-8845-BD4E-CB4CCA059FC4}" type="datetimeFigureOut">
               <a:rPr lang="en-US" smtClean="0"/>
-              <a:t>1/27/13</a:t>
+              <a:t>7/27/26</a:t>
             </a:fld>
             <a:endParaRPr lang="en-US"/>
           </a:p>
@@ -924,10 +1368,9 @@
           </a:lstStyle>
           <a:p>
             <a:r>
-              <a:rPr lang="en-US" smtClean="0"/>
+              <a:rPr lang="en-US"/>
               <a:t>Click to edit Master title style</a:t>
             </a:r>
-            <a:endParaRPr lang="en-US"/>
           </a:p>
         </p:txBody>
       </p:sp>
@@ -1044,7 +1487,7 @@
           <a:p>
             <a:pPr lvl="0"/>
             <a:r>
-              <a:rPr lang="en-US" smtClean="0"/>
+              <a:rPr lang="en-US"/>
               <a:t>Click to edit Master text styles</a:t>
             </a:r>
           </a:p>
@@ -1067,7 +1510,7 @@
           <a:p>
             <a:fld id="{5BCAD085-E8A6-8845-BD4E-CB4CCA059FC4}" type="datetimeFigureOut">
               <a:rPr lang="en-US" smtClean="0"/>
-              <a:t>1/27/13</a:t>
+              <a:t>7/27/26</a:t>
             </a:fld>
             <a:endParaRPr lang="en-US"/>
           </a:p>
@@ -1161,10 +1604,9 @@
           <a:lstStyle/>
           <a:p>
             <a:r>
-              <a:rPr lang="en-US" smtClean="0"/>
+              <a:rPr lang="en-US"/>
               <a:t>Click to edit Master title style</a:t>
             </a:r>
-            <a:endParaRPr lang="en-US"/>
           </a:p>
         </p:txBody>
       </p:sp>
@@ -1218,38 +1660,37 @@
           <a:p>
             <a:pPr lvl="0"/>
             <a:r>
-              <a:rPr lang="en-US" smtClean="0"/>
+              <a:rPr lang="en-US"/>
               <a:t>Click to edit Master text styles</a:t>
             </a:r>
           </a:p>
           <a:p>
             <a:pPr lvl="1"/>
             <a:r>
-              <a:rPr lang="en-US" smtClean="0"/>
+              <a:rPr lang="en-US"/>
               <a:t>Second level</a:t>
             </a:r>
           </a:p>
           <a:p>
             <a:pPr lvl="2"/>
             <a:r>
-              <a:rPr lang="en-US" smtClean="0"/>
+              <a:rPr lang="en-US"/>
               <a:t>Third level</a:t>
             </a:r>
           </a:p>
           <a:p>
             <a:pPr lvl="3"/>
             <a:r>
-              <a:rPr lang="en-US" smtClean="0"/>
+              <a:rPr lang="en-US"/>
               <a:t>Fourth level</a:t>
             </a:r>
           </a:p>
           <a:p>
             <a:pPr lvl="4"/>
             <a:r>
-              <a:rPr lang="en-US" smtClean="0"/>
+              <a:rPr lang="en-US"/>
               <a:t>Fifth level</a:t>
             </a:r>
-            <a:endParaRPr lang="en-US"/>
           </a:p>
         </p:txBody>
       </p:sp>
@@ -1303,38 +1744,37 @@
           <a:p>
             <a:pPr lvl="0"/>
             <a:r>
-              <a:rPr lang="en-US" smtClean="0"/>
+              <a:rPr lang="en-US"/>
               <a:t>Click to edit Master text styles</a:t>
             </a:r>
           </a:p>
           <a:p>
             <a:pPr lvl="1"/>
             <a:r>
-              <a:rPr lang="en-US" smtClean="0"/>
+              <a:rPr lang="en-US"/>
               <a:t>Second level</a:t>
             </a:r>
           </a:p>
           <a:p>
             <a:pPr lvl="2"/>
             <a:r>
-              <a:rPr lang="en-US" smtClean="0"/>
+              <a:rPr lang="en-US"/>
               <a:t>Third level</a:t>
             </a:r>
           </a:p>
           <a:p>
             <a:pPr lvl="3"/>
             <a:r>
-              <a:rPr lang="en-US" smtClean="0"/>
+              <a:rPr lang="en-US"/>
               <a:t>Fourth level</a:t>
             </a:r>
           </a:p>
           <a:p>
             <a:pPr lvl="4"/>
             <a:r>
-              <a:rPr lang="en-US" smtClean="0"/>
+              <a:rPr lang="en-US"/>
               <a:t>Fifth level</a:t>
             </a:r>
-            <a:endParaRPr lang="en-US"/>
           </a:p>
         </p:txBody>
       </p:sp>
@@ -1355,7 +1795,7 @@
           <a:p>
             <a:fld id="{5BCAD085-E8A6-8845-BD4E-CB4CCA059FC4}" type="datetimeFigureOut">
               <a:rPr lang="en-US" smtClean="0"/>
-              <a:t>1/27/13</a:t>
+              <a:t>7/27/26</a:t>
             </a:fld>
             <a:endParaRPr lang="en-US"/>
           </a:p>
@@ -1453,10 +1893,9 @@
           </a:lstStyle>
           <a:p>
             <a:r>
-              <a:rPr lang="en-US" smtClean="0"/>
+              <a:rPr lang="en-US"/>
               <a:t>Click to edit Master title style</a:t>
             </a:r>
-            <a:endParaRPr lang="en-US"/>
           </a:p>
         </p:txBody>
       </p:sp>
@@ -1519,7 +1958,7 @@
           <a:p>
             <a:pPr lvl="0"/>
             <a:r>
-              <a:rPr lang="en-US" smtClean="0"/>
+              <a:rPr lang="en-US"/>
               <a:t>Click to edit Master text styles</a:t>
             </a:r>
           </a:p>
@@ -1575,38 +2014,37 @@
           <a:p>
             <a:pPr lvl="0"/>
             <a:r>
-              <a:rPr lang="en-US" smtClean="0"/>
+              <a:rPr lang="en-US"/>
               <a:t>Click to edit Master text styles</a:t>
             </a:r>
           </a:p>
           <a:p>
             <a:pPr lvl="1"/>
             <a:r>
-              <a:rPr lang="en-US" smtClean="0"/>
+              <a:rPr lang="en-US"/>
               <a:t>Second level</a:t>
             </a:r>
           </a:p>
           <a:p>
             <a:pPr lvl="2"/>
             <a:r>
-              <a:rPr lang="en-US" smtClean="0"/>
+              <a:rPr lang="en-US"/>
               <a:t>Third level</a:t>
             </a:r>
           </a:p>
           <a:p>
             <a:pPr lvl="3"/>
             <a:r>
-              <a:rPr lang="en-US" smtClean="0"/>
+              <a:rPr lang="en-US"/>
               <a:t>Fourth level</a:t>
             </a:r>
           </a:p>
           <a:p>
             <a:pPr lvl="4"/>
             <a:r>
-              <a:rPr lang="en-US" smtClean="0"/>
+              <a:rPr lang="en-US"/>
               <a:t>Fifth level</a:t>
             </a:r>
-            <a:endParaRPr lang="en-US"/>
           </a:p>
         </p:txBody>
       </p:sp>
@@ -1669,7 +2107,7 @@
           <a:p>
             <a:pPr lvl="0"/>
             <a:r>
-              <a:rPr lang="en-US" smtClean="0"/>
+              <a:rPr lang="en-US"/>
               <a:t>Click to edit Master text styles</a:t>
             </a:r>
           </a:p>
@@ -1725,38 +2163,37 @@
           <a:p>
             <a:pPr lvl="0"/>
             <a:r>
-              <a:rPr lang="en-US" smtClean="0"/>
+              <a:rPr lang="en-US"/>
               <a:t>Click to edit Master text styles</a:t>
             </a:r>
           </a:p>
           <a:p>
             <a:pPr lvl="1"/>
             <a:r>
-              <a:rPr lang="en-US" smtClean="0"/>
+              <a:rPr lang="en-US"/>
               <a:t>Second level</a:t>
             </a:r>
           </a:p>
           <a:p>
             <a:pPr lvl="2"/>
             <a:r>
-              <a:rPr lang="en-US" smtClean="0"/>
+              <a:rPr lang="en-US"/>
               <a:t>Third level</a:t>
             </a:r>
           </a:p>
           <a:p>
             <a:pPr lvl="3"/>
             <a:r>
-              <a:rPr lang="en-US" smtClean="0"/>
+              <a:rPr lang="en-US"/>
               <a:t>Fourth level</a:t>
             </a:r>
           </a:p>
           <a:p>
             <a:pPr lvl="4"/>
             <a:r>
-              <a:rPr lang="en-US" smtClean="0"/>
+              <a:rPr lang="en-US"/>
               <a:t>Fifth level</a:t>
             </a:r>
-            <a:endParaRPr lang="en-US"/>
           </a:p>
         </p:txBody>
       </p:sp>
@@ -1777,7 +2214,7 @@
           <a:p>
             <a:fld id="{5BCAD085-E8A6-8845-BD4E-CB4CCA059FC4}" type="datetimeFigureOut">
               <a:rPr lang="en-US" smtClean="0"/>
-              <a:t>1/27/13</a:t>
+              <a:t>7/27/26</a:t>
             </a:fld>
             <a:endParaRPr lang="en-US"/>
           </a:p>
@@ -1871,10 +2308,9 @@
           <a:lstStyle/>
           <a:p>
             <a:r>
-              <a:rPr lang="en-US" smtClean="0"/>
+              <a:rPr lang="en-US"/>
               <a:t>Click to edit Master title style</a:t>
             </a:r>
-            <a:endParaRPr lang="en-US"/>
           </a:p>
         </p:txBody>
       </p:sp>
@@ -1895,7 +2331,7 @@
           <a:p>
             <a:fld id="{5BCAD085-E8A6-8845-BD4E-CB4CCA059FC4}" type="datetimeFigureOut">
               <a:rPr lang="en-US" smtClean="0"/>
-              <a:t>1/27/13</a:t>
+              <a:t>7/27/26</a:t>
             </a:fld>
             <a:endParaRPr lang="en-US"/>
           </a:p>
@@ -1990,7 +2426,7 @@
           <a:p>
             <a:fld id="{5BCAD085-E8A6-8845-BD4E-CB4CCA059FC4}" type="datetimeFigureOut">
               <a:rPr lang="en-US" smtClean="0"/>
-              <a:t>1/27/13</a:t>
+              <a:t>7/27/26</a:t>
             </a:fld>
             <a:endParaRPr lang="en-US"/>
           </a:p>
@@ -2093,10 +2529,9 @@
           </a:lstStyle>
           <a:p>
             <a:r>
-              <a:rPr lang="en-US" smtClean="0"/>
+              <a:rPr lang="en-US"/>
               <a:t>Click to edit Master title style</a:t>
             </a:r>
-            <a:endParaRPr lang="en-US"/>
           </a:p>
         </p:txBody>
       </p:sp>
@@ -2150,38 +2585,37 @@
           <a:p>
             <a:pPr lvl="0"/>
             <a:r>
-              <a:rPr lang="en-US" smtClean="0"/>
+              <a:rPr lang="en-US"/>
               <a:t>Click to edit Master text styles</a:t>
             </a:r>
           </a:p>
           <a:p>
             <a:pPr lvl="1"/>
             <a:r>
-              <a:rPr lang="en-US" smtClean="0"/>
+              <a:rPr lang="en-US"/>
               <a:t>Second level</a:t>
             </a:r>
           </a:p>
           <a:p>
             <a:pPr lvl="2"/>
             <a:r>
-              <a:rPr lang="en-US" smtClean="0"/>
+              <a:rPr lang="en-US"/>
               <a:t>Third level</a:t>
             </a:r>
           </a:p>
           <a:p>
             <a:pPr lvl="3"/>
             <a:r>
-              <a:rPr lang="en-US" smtClean="0"/>
+              <a:rPr lang="en-US"/>
               <a:t>Fourth level</a:t>
             </a:r>
           </a:p>
           <a:p>
             <a:pPr lvl="4"/>
             <a:r>
-              <a:rPr lang="en-US" smtClean="0"/>
+              <a:rPr lang="en-US"/>
               <a:t>Fifth level</a:t>
             </a:r>
-            <a:endParaRPr lang="en-US"/>
           </a:p>
         </p:txBody>
       </p:sp>
@@ -2244,7 +2678,7 @@
           <a:p>
             <a:pPr lvl="0"/>
             <a:r>
-              <a:rPr lang="en-US" smtClean="0"/>
+              <a:rPr lang="en-US"/>
               <a:t>Click to edit Master text styles</a:t>
             </a:r>
           </a:p>
@@ -2267,7 +2701,7 @@
           <a:p>
             <a:fld id="{5BCAD085-E8A6-8845-BD4E-CB4CCA059FC4}" type="datetimeFigureOut">
               <a:rPr lang="en-US" smtClean="0"/>
-              <a:t>1/27/13</a:t>
+              <a:t>7/27/26</a:t>
             </a:fld>
             <a:endParaRPr lang="en-US"/>
           </a:p>
@@ -2370,10 +2804,9 @@
           </a:lstStyle>
           <a:p>
             <a:r>
-              <a:rPr lang="en-US" smtClean="0"/>
+              <a:rPr lang="en-US"/>
               <a:t>Click to edit Master title style</a:t>
             </a:r>
-            <a:endParaRPr lang="en-US"/>
           </a:p>
         </p:txBody>
       </p:sp>
@@ -2497,7 +2930,7 @@
           <a:p>
             <a:pPr lvl="0"/>
             <a:r>
-              <a:rPr lang="en-US" smtClean="0"/>
+              <a:rPr lang="en-US"/>
               <a:t>Click to edit Master text styles</a:t>
             </a:r>
           </a:p>
@@ -2520,7 +2953,7 @@
           <a:p>
             <a:fld id="{5BCAD085-E8A6-8845-BD4E-CB4CCA059FC4}" type="datetimeFigureOut">
               <a:rPr lang="en-US" smtClean="0"/>
-              <a:t>1/27/13</a:t>
+              <a:t>7/27/26</a:t>
             </a:fld>
             <a:endParaRPr lang="en-US"/>
           </a:p>
@@ -2629,10 +3062,9 @@
           <a:lstStyle/>
           <a:p>
             <a:r>
-              <a:rPr lang="en-US" smtClean="0"/>
+              <a:rPr lang="en-US"/>
               <a:t>Click to edit Master title style</a:t>
             </a:r>
-            <a:endParaRPr lang="en-US"/>
           </a:p>
         </p:txBody>
       </p:sp>
@@ -2663,38 +3095,37 @@
           <a:p>
             <a:pPr lvl="0"/>
             <a:r>
-              <a:rPr lang="en-US" smtClean="0"/>
+              <a:rPr lang="en-US"/>
               <a:t>Click to edit Master text styles</a:t>
             </a:r>
           </a:p>
           <a:p>
             <a:pPr lvl="1"/>
             <a:r>
-              <a:rPr lang="en-US" smtClean="0"/>
+              <a:rPr lang="en-US"/>
               <a:t>Second level</a:t>
             </a:r>
           </a:p>
           <a:p>
             <a:pPr lvl="2"/>
             <a:r>
-              <a:rPr lang="en-US" smtClean="0"/>
+              <a:rPr lang="en-US"/>
               <a:t>Third level</a:t>
             </a:r>
           </a:p>
           <a:p>
             <a:pPr lvl="3"/>
             <a:r>
-              <a:rPr lang="en-US" smtClean="0"/>
+              <a:rPr lang="en-US"/>
               <a:t>Fourth level</a:t>
             </a:r>
           </a:p>
           <a:p>
             <a:pPr lvl="4"/>
             <a:r>
-              <a:rPr lang="en-US" smtClean="0"/>
+              <a:rPr lang="en-US"/>
               <a:t>Fifth level</a:t>
             </a:r>
-            <a:endParaRPr lang="en-US"/>
           </a:p>
         </p:txBody>
       </p:sp>
@@ -2733,7 +3164,7 @@
           <a:p>
             <a:fld id="{5BCAD085-E8A6-8845-BD4E-CB4CCA059FC4}" type="datetimeFigureOut">
               <a:rPr lang="en-US" smtClean="0"/>
-              <a:t>1/27/13</a:t>
+              <a:t>7/27/26</a:t>
             </a:fld>
             <a:endParaRPr lang="en-US"/>
           </a:p>
@@ -3092,7 +3523,7 @@
 </file>
 
 <file path=ppt/slides/slide1.xml><?xml version="1.0" encoding="utf-8"?>
-<p:sld xmlns:a="http://schemas.openxmlformats.org/drawingml/2006/main" xmlns:p="http://schemas.openxmlformats.org/presentationml/2006/main" xmlns:r="http://schemas.openxmlformats.org/officeDocument/2006/relationships">
+<p:sld xmlns:a="http://schemas.openxmlformats.org/drawingml/2006/main" xmlns:r="http://schemas.openxmlformats.org/officeDocument/2006/relationships" xmlns:p="http://schemas.openxmlformats.org/presentationml/2006/main">
   <p:cSld>
     <p:bg>
       <p:bgPr>
@@ -3108,7 +3539,14 @@
         <p:cNvGrpSpPr/>
         <p:nvPr/>
       </p:nvGrpSpPr>
-      <p:grpSpPr/>
+      <p:grpSpPr>
+        <a:xfrm>
+          <a:off x="0" y="0"/>
+          <a:ext cx="0" cy="0"/>
+          <a:chOff x="0" y="0"/>
+          <a:chExt cx="0" cy="0"/>
+        </a:xfrm>
+      </p:grpSpPr>
       <p:sp>
         <p:nvSpPr>
           <p:cNvPr id="2" name="Rectangle 1"/>
@@ -3150,6 +3588,7 @@
           <a:lstStyle/>
           <a:p>
             <a:pPr algn="ctr"/>
+            <a:endParaRPr/>
           </a:p>
         </p:txBody>
       </p:sp>
@@ -3194,6 +3633,7 @@
           <a:lstStyle/>
           <a:p>
             <a:pPr algn="ctr"/>
+            <a:endParaRPr/>
           </a:p>
         </p:txBody>
       </p:sp>
@@ -3214,14 +3654,14 @@
           <a:noFill/>
         </p:spPr>
         <p:txBody>
-          <a:bodyPr wrap="square" anchor="t" lIns="0" rIns="0" tIns="0" bIns="0">
+          <a:bodyPr wrap="square" lIns="0" tIns="0" rIns="0" bIns="0" anchor="t">
             <a:spAutoFit/>
           </a:bodyPr>
           <a:lstStyle/>
           <a:p>
             <a:pPr algn="l"/>
             <a:r>
-              <a:rPr sz="1200" b="1">
+              <a:rPr sz="1200" b="1" dirty="0">
                 <a:solidFill>
                   <a:srgbClr val="2A78D6"/>
                 </a:solidFill>
@@ -3249,14 +3689,14 @@
           <a:noFill/>
         </p:spPr>
         <p:txBody>
-          <a:bodyPr wrap="square" anchor="t" lIns="0" rIns="0" tIns="0" bIns="0">
+          <a:bodyPr wrap="square" lIns="0" tIns="0" rIns="0" bIns="0" anchor="t">
             <a:spAutoFit/>
           </a:bodyPr>
           <a:lstStyle/>
           <a:p>
             <a:pPr algn="l"/>
             <a:r>
-              <a:rPr sz="4200" b="1">
+              <a:rPr sz="4200" b="1" dirty="0">
                 <a:solidFill>
                   <a:srgbClr val="0B0B0B"/>
                 </a:solidFill>
@@ -3268,7 +3708,7 @@
           <a:p>
             <a:pPr algn="l"/>
             <a:r>
-              <a:rPr sz="4200" b="1">
+              <a:rPr sz="4200" b="1" dirty="0">
                 <a:solidFill>
                   <a:srgbClr val="0B0B0B"/>
                 </a:solidFill>
@@ -3296,7 +3736,7 @@
           <a:noFill/>
         </p:spPr>
         <p:txBody>
-          <a:bodyPr wrap="square" anchor="t" lIns="0" rIns="0" tIns="0" bIns="0">
+          <a:bodyPr wrap="square" lIns="0" tIns="0" rIns="0" bIns="0" anchor="t">
             <a:spAutoFit/>
           </a:bodyPr>
           <a:lstStyle/>
@@ -3359,6 +3799,7 @@
           <a:lstStyle/>
           <a:p>
             <a:pPr algn="ctr"/>
+            <a:endParaRPr/>
           </a:p>
         </p:txBody>
       </p:sp>
@@ -3379,7 +3820,7 @@
           <a:noFill/>
         </p:spPr>
         <p:txBody>
-          <a:bodyPr wrap="square" anchor="t" lIns="0" rIns="0" tIns="0" bIns="0">
+          <a:bodyPr wrap="square" lIns="0" tIns="0" rIns="0" bIns="0" anchor="t">
             <a:spAutoFit/>
           </a:bodyPr>
           <a:lstStyle/>
@@ -3442,6 +3883,7 @@
           <a:lstStyle/>
           <a:p>
             <a:pPr algn="ctr"/>
+            <a:endParaRPr/>
           </a:p>
         </p:txBody>
       </p:sp>
@@ -3486,6 +3928,7 @@
           <a:lstStyle/>
           <a:p>
             <a:pPr algn="ctr"/>
+            <a:endParaRPr/>
           </a:p>
         </p:txBody>
       </p:sp>
@@ -3497,7 +3940,7 @@
         </p:nvSpPr>
         <p:spPr>
           <a:xfrm>
-            <a:off x="1261872" y="5440680"/>
+            <a:off x="1261872" y="5367528"/>
             <a:ext cx="2606040" cy="411480"/>
           </a:xfrm>
           <a:prstGeom prst="rect">
@@ -3506,14 +3949,14 @@
           <a:noFill/>
         </p:spPr>
         <p:txBody>
-          <a:bodyPr wrap="square" anchor="t" lIns="0" rIns="0" tIns="0" bIns="0">
+          <a:bodyPr wrap="square" lIns="0" tIns="0" rIns="0" bIns="0" anchor="t">
             <a:spAutoFit/>
           </a:bodyPr>
           <a:lstStyle/>
           <a:p>
             <a:pPr algn="l"/>
             <a:r>
-              <a:rPr sz="3000" b="1">
+              <a:rPr sz="3000" b="1" dirty="0">
                 <a:solidFill>
                   <a:srgbClr val="0B0B0B"/>
                 </a:solidFill>
@@ -3532,7 +3975,7 @@
         </p:nvSpPr>
         <p:spPr>
           <a:xfrm>
-            <a:off x="1261872" y="5705856"/>
+            <a:off x="1261872" y="5779008"/>
             <a:ext cx="2606040" cy="530352"/>
           </a:xfrm>
           <a:prstGeom prst="rect">
@@ -3541,7 +3984,7 @@
           <a:noFill/>
         </p:spPr>
         <p:txBody>
-          <a:bodyPr wrap="square" anchor="t" lIns="0" rIns="0" tIns="0" bIns="0">
+          <a:bodyPr wrap="square" lIns="0" tIns="0" rIns="0" bIns="0" anchor="t">
             <a:spAutoFit/>
           </a:bodyPr>
           <a:lstStyle/>
@@ -3552,7 +3995,7 @@
               </a:lnSpc>
             </a:pPr>
             <a:r>
-              <a:rPr sz="1100" b="0">
+              <a:rPr sz="1100" b="0" dirty="0">
                 <a:solidFill>
                   <a:srgbClr val="52514E"/>
                 </a:solidFill>
@@ -3608,6 +4051,7 @@
           <a:lstStyle/>
           <a:p>
             <a:pPr algn="ctr"/>
+            <a:endParaRPr/>
           </a:p>
         </p:txBody>
       </p:sp>
@@ -3652,6 +4096,7 @@
           <a:lstStyle/>
           <a:p>
             <a:pPr algn="ctr"/>
+            <a:endParaRPr/>
           </a:p>
         </p:txBody>
       </p:sp>
@@ -3663,7 +4108,7 @@
         </p:nvSpPr>
         <p:spPr>
           <a:xfrm>
-            <a:off x="4572000" y="5440680"/>
+            <a:off x="4556762" y="5336417"/>
             <a:ext cx="2606040" cy="411480"/>
           </a:xfrm>
           <a:prstGeom prst="rect">
@@ -3672,7 +4117,7 @@
           <a:noFill/>
         </p:spPr>
         <p:txBody>
-          <a:bodyPr wrap="square" anchor="t" lIns="0" rIns="0" tIns="0" bIns="0">
+          <a:bodyPr wrap="square" lIns="0" tIns="0" rIns="0" bIns="0" anchor="t">
             <a:spAutoFit/>
           </a:bodyPr>
           <a:lstStyle/>
@@ -3698,7 +4143,7 @@
         </p:nvSpPr>
         <p:spPr>
           <a:xfrm>
-            <a:off x="4572000" y="5705856"/>
+            <a:off x="4565905" y="5794563"/>
             <a:ext cx="2606040" cy="530352"/>
           </a:xfrm>
           <a:prstGeom prst="rect">
@@ -3707,7 +4152,7 @@
           <a:noFill/>
         </p:spPr>
         <p:txBody>
-          <a:bodyPr wrap="square" anchor="t" lIns="0" rIns="0" tIns="0" bIns="0">
+          <a:bodyPr wrap="square" lIns="0" tIns="0" rIns="0" bIns="0" anchor="t">
             <a:spAutoFit/>
           </a:bodyPr>
           <a:lstStyle/>
@@ -3718,7 +4163,7 @@
               </a:lnSpc>
             </a:pPr>
             <a:r>
-              <a:rPr sz="1100" b="0">
+              <a:rPr sz="1100" b="0" dirty="0">
                 <a:solidFill>
                   <a:srgbClr val="52514E"/>
                 </a:solidFill>
@@ -3774,6 +4219,7 @@
           <a:lstStyle/>
           <a:p>
             <a:pPr algn="ctr"/>
+            <a:endParaRPr/>
           </a:p>
         </p:txBody>
       </p:sp>
@@ -3818,6 +4264,7 @@
           <a:lstStyle/>
           <a:p>
             <a:pPr algn="ctr"/>
+            <a:endParaRPr/>
           </a:p>
         </p:txBody>
       </p:sp>
@@ -3838,7 +4285,7 @@
           <a:noFill/>
         </p:spPr>
         <p:txBody>
-          <a:bodyPr wrap="square" anchor="t" lIns="0" rIns="0" tIns="0" bIns="0">
+          <a:bodyPr wrap="square" lIns="0" tIns="0" rIns="0" bIns="0" anchor="t">
             <a:spAutoFit/>
           </a:bodyPr>
           <a:lstStyle/>
@@ -3864,7 +4311,7 @@
         </p:nvSpPr>
         <p:spPr>
           <a:xfrm>
-            <a:off x="7882127" y="5705856"/>
+            <a:off x="7882127" y="5827014"/>
             <a:ext cx="2606040" cy="530352"/>
           </a:xfrm>
           <a:prstGeom prst="rect">
@@ -3873,7 +4320,7 @@
           <a:noFill/>
         </p:spPr>
         <p:txBody>
-          <a:bodyPr wrap="square" anchor="t" lIns="0" rIns="0" tIns="0" bIns="0">
+          <a:bodyPr wrap="square" lIns="0" tIns="0" rIns="0" bIns="0" anchor="t">
             <a:spAutoFit/>
           </a:bodyPr>
           <a:lstStyle/>
@@ -3884,7 +4331,7 @@
               </a:lnSpc>
             </a:pPr>
             <a:r>
-              <a:rPr sz="1100" b="0">
+              <a:rPr sz="1100" b="0" dirty="0">
                 <a:solidFill>
                   <a:srgbClr val="52514E"/>
                 </a:solidFill>
@@ -3912,7 +4359,7 @@
           <a:noFill/>
         </p:spPr>
         <p:txBody>
-          <a:bodyPr wrap="square" anchor="t" lIns="0" rIns="0" tIns="0" bIns="0">
+          <a:bodyPr wrap="square" lIns="0" tIns="0" rIns="0" bIns="0" anchor="t">
             <a:spAutoFit/>
           </a:bodyPr>
           <a:lstStyle/>
@@ -3947,7 +4394,7 @@
           <a:noFill/>
         </p:spPr>
         <p:txBody>
-          <a:bodyPr wrap="square" anchor="t" lIns="0" rIns="0" tIns="0" bIns="0">
+          <a:bodyPr wrap="square" lIns="0" tIns="0" rIns="0" bIns="0" anchor="t">
             <a:spAutoFit/>
           </a:bodyPr>
           <a:lstStyle/>
@@ -3974,7 +4421,7 @@
 </file>
 
 <file path=ppt/slides/slide10.xml><?xml version="1.0" encoding="utf-8"?>
-<p:sld xmlns:a="http://schemas.openxmlformats.org/drawingml/2006/main" xmlns:p="http://schemas.openxmlformats.org/presentationml/2006/main" xmlns:r="http://schemas.openxmlformats.org/officeDocument/2006/relationships">
+<p:sld xmlns:a="http://schemas.openxmlformats.org/drawingml/2006/main" xmlns:r="http://schemas.openxmlformats.org/officeDocument/2006/relationships" xmlns:p="http://schemas.openxmlformats.org/presentationml/2006/main">
   <p:cSld>
     <p:bg>
       <p:bgPr>
@@ -3990,7 +4437,14 @@
         <p:cNvGrpSpPr/>
         <p:nvPr/>
       </p:nvGrpSpPr>
-      <p:grpSpPr/>
+      <p:grpSpPr>
+        <a:xfrm>
+          <a:off x="0" y="0"/>
+          <a:ext cx="0" cy="0"/>
+          <a:chOff x="0" y="0"/>
+          <a:chExt cx="0" cy="0"/>
+        </a:xfrm>
+      </p:grpSpPr>
       <p:sp>
         <p:nvSpPr>
           <p:cNvPr id="2" name="TextBox 1"/>
@@ -4008,7 +4462,7 @@
           <a:noFill/>
         </p:spPr>
         <p:txBody>
-          <a:bodyPr wrap="square" anchor="t" lIns="0" rIns="0" tIns="0" bIns="0">
+          <a:bodyPr wrap="square" lIns="0" tIns="0" rIns="0" bIns="0" anchor="t">
             <a:spAutoFit/>
           </a:bodyPr>
           <a:lstStyle/>
@@ -4067,7 +4521,7 @@
           </a:fontRef>
         </p:style>
         <p:txBody>
-          <a:bodyPr rtlCol="0" anchor="ctr" wrap="none"/>
+          <a:bodyPr wrap="none" rtlCol="0" anchor="ctr"/>
           <a:lstStyle/>
           <a:p>
             <a:pPr algn="ctr"/>
@@ -4109,7 +4563,7 @@
           <a:noFill/>
         </p:spPr>
         <p:txBody>
-          <a:bodyPr wrap="square" anchor="t" lIns="0" rIns="0" tIns="0" bIns="0">
+          <a:bodyPr wrap="square" lIns="0" tIns="0" rIns="0" bIns="0" anchor="t">
             <a:spAutoFit/>
           </a:bodyPr>
           <a:lstStyle/>
@@ -4172,6 +4626,7 @@
           <a:lstStyle/>
           <a:p>
             <a:pPr algn="ctr"/>
+            <a:endParaRPr/>
           </a:p>
         </p:txBody>
       </p:sp>
@@ -4216,6 +4671,7 @@
           <a:lstStyle/>
           <a:p>
             <a:pPr algn="ctr"/>
+            <a:endParaRPr/>
           </a:p>
         </p:txBody>
       </p:sp>
@@ -4236,7 +4692,7 @@
           <a:noFill/>
         </p:spPr>
         <p:txBody>
-          <a:bodyPr wrap="square" anchor="t" lIns="0" rIns="0" tIns="0" bIns="0">
+          <a:bodyPr wrap="square" lIns="0" tIns="0" rIns="0" bIns="0" anchor="t">
             <a:spAutoFit/>
           </a:bodyPr>
           <a:lstStyle/>
@@ -4271,7 +4727,7 @@
           <a:noFill/>
         </p:spPr>
         <p:txBody>
-          <a:bodyPr wrap="square" anchor="t" lIns="0" rIns="0" tIns="0" bIns="0">
+          <a:bodyPr wrap="square" lIns="0" tIns="0" rIns="0" bIns="0" anchor="t">
             <a:spAutoFit/>
           </a:bodyPr>
           <a:lstStyle/>
@@ -4334,6 +4790,7 @@
           <a:lstStyle/>
           <a:p>
             <a:pPr algn="ctr"/>
+            <a:endParaRPr/>
           </a:p>
         </p:txBody>
       </p:sp>
@@ -4378,6 +4835,7 @@
           <a:lstStyle/>
           <a:p>
             <a:pPr algn="ctr"/>
+            <a:endParaRPr/>
           </a:p>
         </p:txBody>
       </p:sp>
@@ -4398,7 +4856,7 @@
           <a:noFill/>
         </p:spPr>
         <p:txBody>
-          <a:bodyPr wrap="square" anchor="t" lIns="0" rIns="0" tIns="0" bIns="0">
+          <a:bodyPr wrap="square" lIns="0" tIns="0" rIns="0" bIns="0" anchor="t">
             <a:spAutoFit/>
           </a:bodyPr>
           <a:lstStyle/>
@@ -4433,7 +4891,7 @@
           <a:noFill/>
         </p:spPr>
         <p:txBody>
-          <a:bodyPr wrap="square" anchor="t" lIns="0" rIns="0" tIns="0" bIns="0">
+          <a:bodyPr wrap="square" lIns="0" tIns="0" rIns="0" bIns="0" anchor="t">
             <a:spAutoFit/>
           </a:bodyPr>
           <a:lstStyle/>
@@ -4500,6 +4958,7 @@
           <a:lstStyle/>
           <a:p>
             <a:pPr algn="ctr"/>
+            <a:endParaRPr/>
           </a:p>
         </p:txBody>
       </p:sp>
@@ -4544,6 +5003,7 @@
           <a:lstStyle/>
           <a:p>
             <a:pPr algn="ctr"/>
+            <a:endParaRPr/>
           </a:p>
         </p:txBody>
       </p:sp>
@@ -4564,7 +5024,7 @@
           <a:noFill/>
         </p:spPr>
         <p:txBody>
-          <a:bodyPr wrap="square" anchor="t" lIns="0" rIns="0" tIns="0" bIns="0">
+          <a:bodyPr wrap="square" lIns="0" tIns="0" rIns="0" bIns="0" anchor="t">
             <a:spAutoFit/>
           </a:bodyPr>
           <a:lstStyle/>
@@ -4599,7 +5059,7 @@
           <a:noFill/>
         </p:spPr>
         <p:txBody>
-          <a:bodyPr wrap="square" anchor="t" lIns="0" rIns="0" tIns="0" bIns="0">
+          <a:bodyPr wrap="square" lIns="0" tIns="0" rIns="0" bIns="0" anchor="t">
             <a:spAutoFit/>
           </a:bodyPr>
           <a:lstStyle/>
@@ -4616,7 +5076,7 @@
                 </a:solidFill>
                 <a:latin typeface="Arial"/>
               </a:rPr>
-              <a:t>weak: right sign, but fail a layer</a:t>
+              <a:t>weak: right sign, but fails a layer</a:t>
             </a:r>
           </a:p>
         </p:txBody>
@@ -4666,6 +5126,7 @@
           <a:lstStyle/>
           <a:p>
             <a:pPr algn="ctr"/>
+            <a:endParaRPr/>
           </a:p>
         </p:txBody>
       </p:sp>
@@ -4710,6 +5171,7 @@
           <a:lstStyle/>
           <a:p>
             <a:pPr algn="ctr"/>
+            <a:endParaRPr/>
           </a:p>
         </p:txBody>
       </p:sp>
@@ -4730,7 +5192,7 @@
           <a:noFill/>
         </p:spPr>
         <p:txBody>
-          <a:bodyPr wrap="square" anchor="t" lIns="0" rIns="0" tIns="0" bIns="0">
+          <a:bodyPr wrap="square" lIns="0" tIns="0" rIns="0" bIns="0" anchor="t">
             <a:spAutoFit/>
           </a:bodyPr>
           <a:lstStyle/>
@@ -4765,7 +5227,7 @@
           <a:noFill/>
         </p:spPr>
         <p:txBody>
-          <a:bodyPr wrap="square" anchor="t" lIns="0" rIns="0" tIns="0" bIns="0">
+          <a:bodyPr wrap="square" lIns="0" tIns="0" rIns="0" bIns="0" anchor="t">
             <a:spAutoFit/>
           </a:bodyPr>
           <a:lstStyle/>
@@ -4804,7 +5266,7 @@
           <a:noFill/>
         </p:spPr>
         <p:txBody>
-          <a:bodyPr wrap="square" lIns="0" rIns="0" tIns="0" bIns="0">
+          <a:bodyPr wrap="square" lIns="0" tIns="0" rIns="0" bIns="0">
             <a:spAutoFit/>
           </a:bodyPr>
           <a:lstStyle/>
@@ -4903,7 +5365,7 @@
 </file>
 
 <file path=ppt/slides/slide11.xml><?xml version="1.0" encoding="utf-8"?>
-<p:sld xmlns:a="http://schemas.openxmlformats.org/drawingml/2006/main" xmlns:p="http://schemas.openxmlformats.org/presentationml/2006/main" xmlns:r="http://schemas.openxmlformats.org/officeDocument/2006/relationships">
+<p:sld xmlns:a="http://schemas.openxmlformats.org/drawingml/2006/main" xmlns:r="http://schemas.openxmlformats.org/officeDocument/2006/relationships" xmlns:p="http://schemas.openxmlformats.org/presentationml/2006/main">
   <p:cSld>
     <p:bg>
       <p:bgPr>
@@ -4919,7 +5381,14 @@
         <p:cNvGrpSpPr/>
         <p:nvPr/>
       </p:nvGrpSpPr>
-      <p:grpSpPr/>
+      <p:grpSpPr>
+        <a:xfrm>
+          <a:off x="0" y="0"/>
+          <a:ext cx="0" cy="0"/>
+          <a:chOff x="0" y="0"/>
+          <a:chExt cx="0" cy="0"/>
+        </a:xfrm>
+      </p:grpSpPr>
       <p:sp>
         <p:nvSpPr>
           <p:cNvPr id="2" name="TextBox 1"/>
@@ -4937,7 +5406,7 @@
           <a:noFill/>
         </p:spPr>
         <p:txBody>
-          <a:bodyPr wrap="square" anchor="t" lIns="0" rIns="0" tIns="0" bIns="0">
+          <a:bodyPr wrap="square" lIns="0" tIns="0" rIns="0" bIns="0" anchor="t">
             <a:spAutoFit/>
           </a:bodyPr>
           <a:lstStyle/>
@@ -4996,7 +5465,7 @@
           </a:fontRef>
         </p:style>
         <p:txBody>
-          <a:bodyPr rtlCol="0" anchor="ctr" wrap="none"/>
+          <a:bodyPr wrap="none" rtlCol="0" anchor="ctr"/>
           <a:lstStyle/>
           <a:p>
             <a:pPr algn="ctr"/>
@@ -5038,7 +5507,7 @@
           <a:noFill/>
         </p:spPr>
         <p:txBody>
-          <a:bodyPr wrap="square" anchor="t" lIns="0" rIns="0" tIns="0" bIns="0">
+          <a:bodyPr wrap="square" lIns="0" tIns="0" rIns="0" bIns="0" anchor="t">
             <a:spAutoFit/>
           </a:bodyPr>
           <a:lstStyle/>
@@ -5101,6 +5570,7 @@
           <a:lstStyle/>
           <a:p>
             <a:pPr algn="ctr"/>
+            <a:endParaRPr/>
           </a:p>
         </p:txBody>
       </p:sp>
@@ -5145,6 +5615,7 @@
           <a:lstStyle/>
           <a:p>
             <a:pPr algn="ctr"/>
+            <a:endParaRPr/>
           </a:p>
         </p:txBody>
       </p:sp>
@@ -5165,7 +5636,7 @@
           <a:noFill/>
         </p:spPr>
         <p:txBody>
-          <a:bodyPr wrap="square" anchor="t" lIns="0" rIns="0" tIns="0" bIns="0">
+          <a:bodyPr wrap="square" lIns="0" tIns="0" rIns="0" bIns="0" anchor="t">
             <a:spAutoFit/>
           </a:bodyPr>
           <a:lstStyle/>
@@ -5200,7 +5671,7 @@
           <a:noFill/>
         </p:spPr>
         <p:txBody>
-          <a:bodyPr wrap="square" anchor="t" lIns="0" rIns="0" tIns="0" bIns="0">
+          <a:bodyPr wrap="square" lIns="0" tIns="0" rIns="0" bIns="0" anchor="t">
             <a:spAutoFit/>
           </a:bodyPr>
           <a:lstStyle/>
@@ -5263,6 +5734,7 @@
           <a:lstStyle/>
           <a:p>
             <a:pPr algn="ctr"/>
+            <a:endParaRPr/>
           </a:p>
         </p:txBody>
       </p:sp>
@@ -5307,6 +5779,7 @@
           <a:lstStyle/>
           <a:p>
             <a:pPr algn="ctr"/>
+            <a:endParaRPr/>
           </a:p>
         </p:txBody>
       </p:sp>
@@ -5327,7 +5800,7 @@
           <a:noFill/>
         </p:spPr>
         <p:txBody>
-          <a:bodyPr wrap="square" anchor="t" lIns="0" rIns="0" tIns="0" bIns="0">
+          <a:bodyPr wrap="square" lIns="0" tIns="0" rIns="0" bIns="0" anchor="t">
             <a:spAutoFit/>
           </a:bodyPr>
           <a:lstStyle/>
@@ -5362,7 +5835,7 @@
           <a:noFill/>
         </p:spPr>
         <p:txBody>
-          <a:bodyPr wrap="square" anchor="t" lIns="0" rIns="0" tIns="0" bIns="0">
+          <a:bodyPr wrap="square" lIns="0" tIns="0" rIns="0" bIns="0" anchor="t">
             <a:spAutoFit/>
           </a:bodyPr>
           <a:lstStyle/>
@@ -5429,6 +5902,7 @@
           <a:lstStyle/>
           <a:p>
             <a:pPr algn="ctr"/>
+            <a:endParaRPr/>
           </a:p>
         </p:txBody>
       </p:sp>
@@ -5473,6 +5947,7 @@
           <a:lstStyle/>
           <a:p>
             <a:pPr algn="ctr"/>
+            <a:endParaRPr/>
           </a:p>
         </p:txBody>
       </p:sp>
@@ -5493,7 +5968,7 @@
           <a:noFill/>
         </p:spPr>
         <p:txBody>
-          <a:bodyPr wrap="square" anchor="t" lIns="0" rIns="0" tIns="0" bIns="0">
+          <a:bodyPr wrap="square" lIns="0" tIns="0" rIns="0" bIns="0" anchor="t">
             <a:spAutoFit/>
           </a:bodyPr>
           <a:lstStyle/>
@@ -5528,7 +6003,7 @@
           <a:noFill/>
         </p:spPr>
         <p:txBody>
-          <a:bodyPr wrap="square" anchor="t" lIns="0" rIns="0" tIns="0" bIns="0">
+          <a:bodyPr wrap="square" lIns="0" tIns="0" rIns="0" bIns="0" anchor="t">
             <a:spAutoFit/>
           </a:bodyPr>
           <a:lstStyle/>
@@ -5595,6 +6070,7 @@
           <a:lstStyle/>
           <a:p>
             <a:pPr algn="ctr"/>
+            <a:endParaRPr/>
           </a:p>
         </p:txBody>
       </p:sp>
@@ -5639,6 +6115,7 @@
           <a:lstStyle/>
           <a:p>
             <a:pPr algn="ctr"/>
+            <a:endParaRPr/>
           </a:p>
         </p:txBody>
       </p:sp>
@@ -5659,7 +6136,7 @@
           <a:noFill/>
         </p:spPr>
         <p:txBody>
-          <a:bodyPr wrap="square" anchor="t" lIns="0" rIns="0" tIns="0" bIns="0">
+          <a:bodyPr wrap="square" lIns="0" tIns="0" rIns="0" bIns="0" anchor="t">
             <a:spAutoFit/>
           </a:bodyPr>
           <a:lstStyle/>
@@ -5694,7 +6171,7 @@
           <a:noFill/>
         </p:spPr>
         <p:txBody>
-          <a:bodyPr wrap="square" anchor="t" lIns="0" rIns="0" tIns="0" bIns="0">
+          <a:bodyPr wrap="square" lIns="0" tIns="0" rIns="0" bIns="0" anchor="t">
             <a:spAutoFit/>
           </a:bodyPr>
           <a:lstStyle/>
@@ -5733,7 +6210,7 @@
           <a:noFill/>
         </p:spPr>
         <p:txBody>
-          <a:bodyPr wrap="square" lIns="0" rIns="0" tIns="0" bIns="0">
+          <a:bodyPr wrap="square" lIns="0" tIns="0" rIns="0" bIns="0">
             <a:spAutoFit/>
           </a:bodyPr>
           <a:lstStyle/>
@@ -5832,7 +6309,7 @@
 </file>
 
 <file path=ppt/slides/slide12.xml><?xml version="1.0" encoding="utf-8"?>
-<p:sld xmlns:a="http://schemas.openxmlformats.org/drawingml/2006/main" xmlns:p="http://schemas.openxmlformats.org/presentationml/2006/main" xmlns:r="http://schemas.openxmlformats.org/officeDocument/2006/relationships">
+<p:sld xmlns:a="http://schemas.openxmlformats.org/drawingml/2006/main" xmlns:r="http://schemas.openxmlformats.org/officeDocument/2006/relationships" xmlns:p="http://schemas.openxmlformats.org/presentationml/2006/main">
   <p:cSld>
     <p:bg>
       <p:bgPr>
@@ -5848,7 +6325,14 @@
         <p:cNvGrpSpPr/>
         <p:nvPr/>
       </p:nvGrpSpPr>
-      <p:grpSpPr/>
+      <p:grpSpPr>
+        <a:xfrm>
+          <a:off x="0" y="0"/>
+          <a:ext cx="0" cy="0"/>
+          <a:chOff x="0" y="0"/>
+          <a:chExt cx="0" cy="0"/>
+        </a:xfrm>
+      </p:grpSpPr>
       <p:sp>
         <p:nvSpPr>
           <p:cNvPr id="2" name="TextBox 1"/>
@@ -5866,7 +6350,7 @@
           <a:noFill/>
         </p:spPr>
         <p:txBody>
-          <a:bodyPr wrap="square" anchor="t" lIns="0" rIns="0" tIns="0" bIns="0">
+          <a:bodyPr wrap="square" lIns="0" tIns="0" rIns="0" bIns="0" anchor="t">
             <a:spAutoFit/>
           </a:bodyPr>
           <a:lstStyle/>
@@ -5925,7 +6409,7 @@
           </a:fontRef>
         </p:style>
         <p:txBody>
-          <a:bodyPr rtlCol="0" anchor="ctr" wrap="none"/>
+          <a:bodyPr wrap="none" rtlCol="0" anchor="ctr"/>
           <a:lstStyle/>
           <a:p>
             <a:pPr algn="ctr"/>
@@ -5967,7 +6451,7 @@
           <a:noFill/>
         </p:spPr>
         <p:txBody>
-          <a:bodyPr wrap="square" anchor="t" lIns="0" rIns="0" tIns="0" bIns="0">
+          <a:bodyPr wrap="square" lIns="0" tIns="0" rIns="0" bIns="0" anchor="t">
             <a:spAutoFit/>
           </a:bodyPr>
           <a:lstStyle/>
@@ -6030,6 +6514,7 @@
           <a:lstStyle/>
           <a:p>
             <a:pPr algn="ctr"/>
+            <a:endParaRPr/>
           </a:p>
         </p:txBody>
       </p:sp>
@@ -6074,6 +6559,7 @@
           <a:lstStyle/>
           <a:p>
             <a:pPr algn="ctr"/>
+            <a:endParaRPr/>
           </a:p>
         </p:txBody>
       </p:sp>
@@ -6094,7 +6580,7 @@
           <a:noFill/>
         </p:spPr>
         <p:txBody>
-          <a:bodyPr wrap="square" anchor="t" lIns="0" rIns="0" tIns="0" bIns="0">
+          <a:bodyPr wrap="square" lIns="0" tIns="0" rIns="0" bIns="0" anchor="t">
             <a:spAutoFit/>
           </a:bodyPr>
           <a:lstStyle/>
@@ -6129,7 +6615,7 @@
           <a:noFill/>
         </p:spPr>
         <p:txBody>
-          <a:bodyPr wrap="square" anchor="t" lIns="0" rIns="0" tIns="0" bIns="0">
+          <a:bodyPr wrap="square" lIns="0" tIns="0" rIns="0" bIns="0" anchor="t">
             <a:spAutoFit/>
           </a:bodyPr>
           <a:lstStyle/>
@@ -6192,6 +6678,7 @@
           <a:lstStyle/>
           <a:p>
             <a:pPr algn="ctr"/>
+            <a:endParaRPr/>
           </a:p>
         </p:txBody>
       </p:sp>
@@ -6236,6 +6723,7 @@
           <a:lstStyle/>
           <a:p>
             <a:pPr algn="ctr"/>
+            <a:endParaRPr/>
           </a:p>
         </p:txBody>
       </p:sp>
@@ -6256,7 +6744,7 @@
           <a:noFill/>
         </p:spPr>
         <p:txBody>
-          <a:bodyPr wrap="square" anchor="t" lIns="0" rIns="0" tIns="0" bIns="0">
+          <a:bodyPr wrap="square" lIns="0" tIns="0" rIns="0" bIns="0" anchor="t">
             <a:spAutoFit/>
           </a:bodyPr>
           <a:lstStyle/>
@@ -6291,7 +6779,7 @@
           <a:noFill/>
         </p:spPr>
         <p:txBody>
-          <a:bodyPr wrap="square" anchor="t" lIns="0" rIns="0" tIns="0" bIns="0">
+          <a:bodyPr wrap="square" lIns="0" tIns="0" rIns="0" bIns="0" anchor="t">
             <a:spAutoFit/>
           </a:bodyPr>
           <a:lstStyle/>
@@ -6358,6 +6846,7 @@
           <a:lstStyle/>
           <a:p>
             <a:pPr algn="ctr"/>
+            <a:endParaRPr/>
           </a:p>
         </p:txBody>
       </p:sp>
@@ -6402,6 +6891,7 @@
           <a:lstStyle/>
           <a:p>
             <a:pPr algn="ctr"/>
+            <a:endParaRPr/>
           </a:p>
         </p:txBody>
       </p:sp>
@@ -6422,7 +6912,7 @@
           <a:noFill/>
         </p:spPr>
         <p:txBody>
-          <a:bodyPr wrap="square" anchor="t" lIns="0" rIns="0" tIns="0" bIns="0">
+          <a:bodyPr wrap="square" lIns="0" tIns="0" rIns="0" bIns="0" anchor="t">
             <a:spAutoFit/>
           </a:bodyPr>
           <a:lstStyle/>
@@ -6457,7 +6947,7 @@
           <a:noFill/>
         </p:spPr>
         <p:txBody>
-          <a:bodyPr wrap="square" anchor="t" lIns="0" rIns="0" tIns="0" bIns="0">
+          <a:bodyPr wrap="square" lIns="0" tIns="0" rIns="0" bIns="0" anchor="t">
             <a:spAutoFit/>
           </a:bodyPr>
           <a:lstStyle/>
@@ -6496,7 +6986,7 @@
           <a:noFill/>
         </p:spPr>
         <p:txBody>
-          <a:bodyPr wrap="square" lIns="0" rIns="0" tIns="0" bIns="0">
+          <a:bodyPr wrap="square" lIns="0" tIns="0" rIns="0" bIns="0">
             <a:spAutoFit/>
           </a:bodyPr>
           <a:lstStyle/>
@@ -6595,7 +7085,7 @@
 </file>
 
 <file path=ppt/slides/slide13.xml><?xml version="1.0" encoding="utf-8"?>
-<p:sld xmlns:a="http://schemas.openxmlformats.org/drawingml/2006/main" xmlns:p="http://schemas.openxmlformats.org/presentationml/2006/main" xmlns:r="http://schemas.openxmlformats.org/officeDocument/2006/relationships">
+<p:sld xmlns:a="http://schemas.openxmlformats.org/drawingml/2006/main" xmlns:r="http://schemas.openxmlformats.org/officeDocument/2006/relationships" xmlns:p="http://schemas.openxmlformats.org/presentationml/2006/main">
   <p:cSld>
     <p:bg>
       <p:bgPr>
@@ -6611,7 +7101,14 @@
         <p:cNvGrpSpPr/>
         <p:nvPr/>
       </p:nvGrpSpPr>
-      <p:grpSpPr/>
+      <p:grpSpPr>
+        <a:xfrm>
+          <a:off x="0" y="0"/>
+          <a:ext cx="0" cy="0"/>
+          <a:chOff x="0" y="0"/>
+          <a:chExt cx="0" cy="0"/>
+        </a:xfrm>
+      </p:grpSpPr>
       <p:sp>
         <p:nvSpPr>
           <p:cNvPr id="2" name="TextBox 1"/>
@@ -6629,7 +7126,7 @@
           <a:noFill/>
         </p:spPr>
         <p:txBody>
-          <a:bodyPr wrap="square" anchor="t" lIns="0" rIns="0" tIns="0" bIns="0">
+          <a:bodyPr wrap="square" lIns="0" tIns="0" rIns="0" bIns="0" anchor="t">
             <a:spAutoFit/>
           </a:bodyPr>
           <a:lstStyle/>
@@ -6688,7 +7185,7 @@
           </a:fontRef>
         </p:style>
         <p:txBody>
-          <a:bodyPr rtlCol="0" anchor="ctr" wrap="none"/>
+          <a:bodyPr wrap="none" rtlCol="0" anchor="ctr"/>
           <a:lstStyle/>
           <a:p>
             <a:pPr algn="ctr"/>
@@ -6730,7 +7227,7 @@
           <a:noFill/>
         </p:spPr>
         <p:txBody>
-          <a:bodyPr wrap="square" anchor="t" lIns="0" rIns="0" tIns="0" bIns="0">
+          <a:bodyPr wrap="square" lIns="0" tIns="0" rIns="0" bIns="0" anchor="t">
             <a:spAutoFit/>
           </a:bodyPr>
           <a:lstStyle/>
@@ -6741,7 +7238,7 @@
               </a:lnSpc>
             </a:pPr>
             <a:r>
-              <a:rPr sz="2700" b="1">
+              <a:rPr sz="2700" b="1" dirty="0">
                 <a:solidFill>
                   <a:srgbClr val="0B0B0B"/>
                 </a:solidFill>
@@ -6793,6 +7290,7 @@
           <a:lstStyle/>
           <a:p>
             <a:pPr algn="ctr"/>
+            <a:endParaRPr/>
           </a:p>
         </p:txBody>
       </p:sp>
@@ -6837,6 +7335,7 @@
           <a:lstStyle/>
           <a:p>
             <a:pPr algn="ctr"/>
+            <a:endParaRPr/>
           </a:p>
         </p:txBody>
       </p:sp>
@@ -6857,7 +7356,7 @@
           <a:noFill/>
         </p:spPr>
         <p:txBody>
-          <a:bodyPr wrap="square" anchor="t" lIns="0" rIns="0" tIns="0" bIns="0">
+          <a:bodyPr wrap="square" lIns="0" tIns="0" rIns="0" bIns="0" anchor="t">
             <a:spAutoFit/>
           </a:bodyPr>
           <a:lstStyle/>
@@ -6892,7 +7391,7 @@
           <a:noFill/>
         </p:spPr>
         <p:txBody>
-          <a:bodyPr wrap="square" anchor="t" lIns="0" rIns="0" tIns="0" bIns="0">
+          <a:bodyPr wrap="square" lIns="0" tIns="0" rIns="0" bIns="0" anchor="t">
             <a:spAutoFit/>
           </a:bodyPr>
           <a:lstStyle/>
@@ -6955,6 +7454,7 @@
           <a:lstStyle/>
           <a:p>
             <a:pPr algn="ctr"/>
+            <a:endParaRPr/>
           </a:p>
         </p:txBody>
       </p:sp>
@@ -6999,6 +7499,7 @@
           <a:lstStyle/>
           <a:p>
             <a:pPr algn="ctr"/>
+            <a:endParaRPr/>
           </a:p>
         </p:txBody>
       </p:sp>
@@ -7019,7 +7520,7 @@
           <a:noFill/>
         </p:spPr>
         <p:txBody>
-          <a:bodyPr wrap="square" anchor="t" lIns="0" rIns="0" tIns="0" bIns="0">
+          <a:bodyPr wrap="square" lIns="0" tIns="0" rIns="0" bIns="0" anchor="t">
             <a:spAutoFit/>
           </a:bodyPr>
           <a:lstStyle/>
@@ -7045,7 +7546,7 @@
         </p:nvSpPr>
         <p:spPr>
           <a:xfrm>
-            <a:off x="941832" y="2551176"/>
+            <a:off x="941832" y="2697480"/>
             <a:ext cx="4251960" cy="530352"/>
           </a:xfrm>
           <a:prstGeom prst="rect">
@@ -7054,7 +7555,7 @@
           <a:noFill/>
         </p:spPr>
         <p:txBody>
-          <a:bodyPr wrap="square" anchor="t" lIns="0" rIns="0" tIns="0" bIns="0">
+          <a:bodyPr wrap="square" lIns="0" tIns="0" rIns="0" bIns="0" anchor="t">
             <a:spAutoFit/>
           </a:bodyPr>
           <a:lstStyle/>
@@ -7065,7 +7566,7 @@
               </a:lnSpc>
             </a:pPr>
             <a:r>
-              <a:rPr sz="1100" b="0">
+              <a:rPr sz="1100" b="0" dirty="0">
                 <a:solidFill>
                   <a:srgbClr val="52514E"/>
                 </a:solidFill>
@@ -7121,6 +7622,7 @@
           <a:lstStyle/>
           <a:p>
             <a:pPr algn="ctr"/>
+            <a:endParaRPr/>
           </a:p>
         </p:txBody>
       </p:sp>
@@ -7165,6 +7667,7 @@
           <a:lstStyle/>
           <a:p>
             <a:pPr algn="ctr"/>
+            <a:endParaRPr/>
           </a:p>
         </p:txBody>
       </p:sp>
@@ -7185,7 +7688,7 @@
           <a:noFill/>
         </p:spPr>
         <p:txBody>
-          <a:bodyPr wrap="square" anchor="t" lIns="0" rIns="0" tIns="0" bIns="0">
+          <a:bodyPr wrap="square" lIns="0" tIns="0" rIns="0" bIns="0" anchor="t">
             <a:spAutoFit/>
           </a:bodyPr>
           <a:lstStyle/>
@@ -7211,7 +7714,7 @@
         </p:nvSpPr>
         <p:spPr>
           <a:xfrm>
-            <a:off x="941832" y="3922776"/>
+            <a:off x="941832" y="4164304"/>
             <a:ext cx="4251960" cy="530352"/>
           </a:xfrm>
           <a:prstGeom prst="rect">
@@ -7220,7 +7723,7 @@
           <a:noFill/>
         </p:spPr>
         <p:txBody>
-          <a:bodyPr wrap="square" anchor="t" lIns="0" rIns="0" tIns="0" bIns="0">
+          <a:bodyPr wrap="square" lIns="0" tIns="0" rIns="0" bIns="0" anchor="t">
             <a:spAutoFit/>
           </a:bodyPr>
           <a:lstStyle/>
@@ -7231,7 +7734,7 @@
               </a:lnSpc>
             </a:pPr>
             <a:r>
-              <a:rPr sz="1100" b="0">
+              <a:rPr sz="1100" b="0" dirty="0">
                 <a:solidFill>
                   <a:srgbClr val="52514E"/>
                 </a:solidFill>
@@ -7287,6 +7790,7 @@
           <a:lstStyle/>
           <a:p>
             <a:pPr algn="ctr"/>
+            <a:endParaRPr/>
           </a:p>
         </p:txBody>
       </p:sp>
@@ -7331,6 +7835,7 @@
           <a:lstStyle/>
           <a:p>
             <a:pPr algn="ctr"/>
+            <a:endParaRPr/>
           </a:p>
         </p:txBody>
       </p:sp>
@@ -7351,7 +7856,7 @@
           <a:noFill/>
         </p:spPr>
         <p:txBody>
-          <a:bodyPr wrap="square" anchor="t" lIns="0" rIns="0" tIns="0" bIns="0">
+          <a:bodyPr wrap="square" lIns="0" tIns="0" rIns="0" bIns="0" anchor="t">
             <a:spAutoFit/>
           </a:bodyPr>
           <a:lstStyle/>
@@ -7377,7 +7882,7 @@
         </p:nvSpPr>
         <p:spPr>
           <a:xfrm>
-            <a:off x="941832" y="5294375"/>
+            <a:off x="941832" y="5432346"/>
             <a:ext cx="4251960" cy="530352"/>
           </a:xfrm>
           <a:prstGeom prst="rect">
@@ -7386,7 +7891,7 @@
           <a:noFill/>
         </p:spPr>
         <p:txBody>
-          <a:bodyPr wrap="square" anchor="t" lIns="0" rIns="0" tIns="0" bIns="0">
+          <a:bodyPr wrap="square" lIns="0" tIns="0" rIns="0" bIns="0" anchor="t">
             <a:spAutoFit/>
           </a:bodyPr>
           <a:lstStyle/>
@@ -7397,7 +7902,7 @@
               </a:lnSpc>
             </a:pPr>
             <a:r>
-              <a:rPr sz="1100" b="0">
+              <a:rPr sz="1100" b="0" dirty="0">
                 <a:solidFill>
                   <a:srgbClr val="52514E"/>
                 </a:solidFill>
@@ -7424,8 +7929,8 @@
         </p:blipFill>
         <p:spPr>
           <a:xfrm>
-            <a:off x="7261607" y="1828800"/>
-            <a:ext cx="2743399" cy="4297680"/>
+            <a:off x="7086600" y="1362582"/>
+            <a:ext cx="3154244" cy="4941291"/>
           </a:xfrm>
           <a:prstGeom prst="rect">
             <a:avLst/>
@@ -7441,7 +7946,7 @@
 </file>
 
 <file path=ppt/slides/slide14.xml><?xml version="1.0" encoding="utf-8"?>
-<p:sld xmlns:a="http://schemas.openxmlformats.org/drawingml/2006/main" xmlns:p="http://schemas.openxmlformats.org/presentationml/2006/main" xmlns:r="http://schemas.openxmlformats.org/officeDocument/2006/relationships">
+<p:sld xmlns:a="http://schemas.openxmlformats.org/drawingml/2006/main" xmlns:r="http://schemas.openxmlformats.org/officeDocument/2006/relationships" xmlns:p="http://schemas.openxmlformats.org/presentationml/2006/main">
   <p:cSld>
     <p:bg>
       <p:bgPr>
@@ -7457,7 +7962,14 @@
         <p:cNvGrpSpPr/>
         <p:nvPr/>
       </p:nvGrpSpPr>
-      <p:grpSpPr/>
+      <p:grpSpPr>
+        <a:xfrm>
+          <a:off x="0" y="0"/>
+          <a:ext cx="0" cy="0"/>
+          <a:chOff x="0" y="0"/>
+          <a:chExt cx="0" cy="0"/>
+        </a:xfrm>
+      </p:grpSpPr>
       <p:sp>
         <p:nvSpPr>
           <p:cNvPr id="2" name="TextBox 1"/>
@@ -7475,7 +7987,7 @@
           <a:noFill/>
         </p:spPr>
         <p:txBody>
-          <a:bodyPr wrap="square" anchor="t" lIns="0" rIns="0" tIns="0" bIns="0">
+          <a:bodyPr wrap="square" lIns="0" tIns="0" rIns="0" bIns="0" anchor="t">
             <a:spAutoFit/>
           </a:bodyPr>
           <a:lstStyle/>
@@ -7534,7 +8046,7 @@
           </a:fontRef>
         </p:style>
         <p:txBody>
-          <a:bodyPr rtlCol="0" anchor="ctr" wrap="none"/>
+          <a:bodyPr wrap="none" rtlCol="0" anchor="ctr"/>
           <a:lstStyle/>
           <a:p>
             <a:pPr algn="ctr"/>
@@ -7576,7 +8088,7 @@
           <a:noFill/>
         </p:spPr>
         <p:txBody>
-          <a:bodyPr wrap="square" anchor="t" lIns="0" rIns="0" tIns="0" bIns="0">
+          <a:bodyPr wrap="square" lIns="0" tIns="0" rIns="0" bIns="0" anchor="t">
             <a:spAutoFit/>
           </a:bodyPr>
           <a:lstStyle/>
@@ -7639,6 +8151,7 @@
           <a:lstStyle/>
           <a:p>
             <a:pPr algn="ctr"/>
+            <a:endParaRPr/>
           </a:p>
         </p:txBody>
       </p:sp>
@@ -7683,6 +8196,7 @@
           <a:lstStyle/>
           <a:p>
             <a:pPr algn="ctr"/>
+            <a:endParaRPr/>
           </a:p>
         </p:txBody>
       </p:sp>
@@ -7703,7 +8217,7 @@
           <a:noFill/>
         </p:spPr>
         <p:txBody>
-          <a:bodyPr wrap="square" anchor="t" lIns="0" rIns="0" tIns="0" bIns="0">
+          <a:bodyPr wrap="square" lIns="0" tIns="0" rIns="0" bIns="0" anchor="t">
             <a:spAutoFit/>
           </a:bodyPr>
           <a:lstStyle/>
@@ -7738,7 +8252,7 @@
           <a:noFill/>
         </p:spPr>
         <p:txBody>
-          <a:bodyPr wrap="square" anchor="t" lIns="0" rIns="0" tIns="0" bIns="0">
+          <a:bodyPr wrap="square" lIns="0" tIns="0" rIns="0" bIns="0" anchor="t">
             <a:spAutoFit/>
           </a:bodyPr>
           <a:lstStyle/>
@@ -7801,6 +8315,7 @@
           <a:lstStyle/>
           <a:p>
             <a:pPr algn="ctr"/>
+            <a:endParaRPr/>
           </a:p>
         </p:txBody>
       </p:sp>
@@ -7845,6 +8360,7 @@
           <a:lstStyle/>
           <a:p>
             <a:pPr algn="ctr"/>
+            <a:endParaRPr/>
           </a:p>
         </p:txBody>
       </p:sp>
@@ -7865,7 +8381,7 @@
           <a:noFill/>
         </p:spPr>
         <p:txBody>
-          <a:bodyPr wrap="square" anchor="t" lIns="0" rIns="0" tIns="0" bIns="0">
+          <a:bodyPr wrap="square" lIns="0" tIns="0" rIns="0" bIns="0" anchor="t">
             <a:spAutoFit/>
           </a:bodyPr>
           <a:lstStyle/>
@@ -7900,7 +8416,7 @@
           <a:noFill/>
         </p:spPr>
         <p:txBody>
-          <a:bodyPr wrap="square" anchor="t" lIns="0" rIns="0" tIns="0" bIns="0">
+          <a:bodyPr wrap="square" lIns="0" tIns="0" rIns="0" bIns="0" anchor="t">
             <a:spAutoFit/>
           </a:bodyPr>
           <a:lstStyle/>
@@ -7967,6 +8483,7 @@
           <a:lstStyle/>
           <a:p>
             <a:pPr algn="ctr"/>
+            <a:endParaRPr/>
           </a:p>
         </p:txBody>
       </p:sp>
@@ -8011,6 +8528,7 @@
           <a:lstStyle/>
           <a:p>
             <a:pPr algn="ctr"/>
+            <a:endParaRPr/>
           </a:p>
         </p:txBody>
       </p:sp>
@@ -8031,7 +8549,7 @@
           <a:noFill/>
         </p:spPr>
         <p:txBody>
-          <a:bodyPr wrap="square" anchor="t" lIns="0" rIns="0" tIns="0" bIns="0">
+          <a:bodyPr wrap="square" lIns="0" tIns="0" rIns="0" bIns="0" anchor="t">
             <a:spAutoFit/>
           </a:bodyPr>
           <a:lstStyle/>
@@ -8066,7 +8584,7 @@
           <a:noFill/>
         </p:spPr>
         <p:txBody>
-          <a:bodyPr wrap="square" anchor="t" lIns="0" rIns="0" tIns="0" bIns="0">
+          <a:bodyPr wrap="square" lIns="0" tIns="0" rIns="0" bIns="0" anchor="t">
             <a:spAutoFit/>
           </a:bodyPr>
           <a:lstStyle/>
@@ -8133,6 +8651,7 @@
           <a:lstStyle/>
           <a:p>
             <a:pPr algn="ctr"/>
+            <a:endParaRPr/>
           </a:p>
         </p:txBody>
       </p:sp>
@@ -8177,6 +8696,7 @@
           <a:lstStyle/>
           <a:p>
             <a:pPr algn="ctr"/>
+            <a:endParaRPr/>
           </a:p>
         </p:txBody>
       </p:sp>
@@ -8197,7 +8717,7 @@
           <a:noFill/>
         </p:spPr>
         <p:txBody>
-          <a:bodyPr wrap="square" anchor="t" lIns="0" rIns="0" tIns="0" bIns="0">
+          <a:bodyPr wrap="square" lIns="0" tIns="0" rIns="0" bIns="0" anchor="t">
             <a:spAutoFit/>
           </a:bodyPr>
           <a:lstStyle/>
@@ -8232,7 +8752,7 @@
           <a:noFill/>
         </p:spPr>
         <p:txBody>
-          <a:bodyPr wrap="square" anchor="t" lIns="0" rIns="0" tIns="0" bIns="0">
+          <a:bodyPr wrap="square" lIns="0" tIns="0" rIns="0" bIns="0" anchor="t">
             <a:spAutoFit/>
           </a:bodyPr>
           <a:lstStyle/>
@@ -8271,7 +8791,7 @@
           <a:noFill/>
         </p:spPr>
         <p:txBody>
-          <a:bodyPr wrap="square" lIns="0" rIns="0" tIns="0" bIns="0">
+          <a:bodyPr wrap="square" lIns="0" tIns="0" rIns="0" bIns="0">
             <a:spAutoFit/>
           </a:bodyPr>
           <a:lstStyle/>
@@ -8378,6 +8898,7 @@
           <a:lstStyle/>
           <a:p>
             <a:pPr algn="ctr"/>
+            <a:endParaRPr/>
           </a:p>
         </p:txBody>
       </p:sp>
@@ -8398,7 +8919,7 @@
           <a:noFill/>
         </p:spPr>
         <p:txBody>
-          <a:bodyPr wrap="square" anchor="ctr" lIns="0" rIns="0" tIns="0" bIns="0">
+          <a:bodyPr wrap="square" lIns="0" tIns="0" rIns="0" bIns="0" anchor="ctr">
             <a:spAutoFit/>
           </a:bodyPr>
           <a:lstStyle/>
@@ -8425,7 +8946,7 @@
 </file>
 
 <file path=ppt/slides/slide2.xml><?xml version="1.0" encoding="utf-8"?>
-<p:sld xmlns:a="http://schemas.openxmlformats.org/drawingml/2006/main" xmlns:p="http://schemas.openxmlformats.org/presentationml/2006/main" xmlns:r="http://schemas.openxmlformats.org/officeDocument/2006/relationships">
+<p:sld xmlns:a="http://schemas.openxmlformats.org/drawingml/2006/main" xmlns:r="http://schemas.openxmlformats.org/officeDocument/2006/relationships" xmlns:p="http://schemas.openxmlformats.org/presentationml/2006/main">
   <p:cSld>
     <p:bg>
       <p:bgPr>
@@ -8441,7 +8962,14 @@
         <p:cNvGrpSpPr/>
         <p:nvPr/>
       </p:nvGrpSpPr>
-      <p:grpSpPr/>
+      <p:grpSpPr>
+        <a:xfrm>
+          <a:off x="0" y="0"/>
+          <a:ext cx="0" cy="0"/>
+          <a:chOff x="0" y="0"/>
+          <a:chExt cx="0" cy="0"/>
+        </a:xfrm>
+      </p:grpSpPr>
       <p:sp>
         <p:nvSpPr>
           <p:cNvPr id="2" name="TextBox 1"/>
@@ -8459,7 +8987,7 @@
           <a:noFill/>
         </p:spPr>
         <p:txBody>
-          <a:bodyPr wrap="square" anchor="t" lIns="0" rIns="0" tIns="0" bIns="0">
+          <a:bodyPr wrap="square" lIns="0" tIns="0" rIns="0" bIns="0" anchor="t">
             <a:spAutoFit/>
           </a:bodyPr>
           <a:lstStyle/>
@@ -8518,7 +9046,7 @@
           </a:fontRef>
         </p:style>
         <p:txBody>
-          <a:bodyPr rtlCol="0" anchor="ctr" wrap="none"/>
+          <a:bodyPr wrap="none" rtlCol="0" anchor="ctr"/>
           <a:lstStyle/>
           <a:p>
             <a:pPr algn="ctr"/>
@@ -8560,7 +9088,7 @@
           <a:noFill/>
         </p:spPr>
         <p:txBody>
-          <a:bodyPr wrap="square" anchor="t" lIns="0" rIns="0" tIns="0" bIns="0">
+          <a:bodyPr wrap="square" lIns="0" tIns="0" rIns="0" bIns="0" anchor="t">
             <a:spAutoFit/>
           </a:bodyPr>
           <a:lstStyle/>
@@ -8623,6 +9151,7 @@
           <a:lstStyle/>
           <a:p>
             <a:pPr algn="ctr"/>
+            <a:endParaRPr/>
           </a:p>
         </p:txBody>
       </p:sp>
@@ -8667,6 +9196,7 @@
           <a:lstStyle/>
           <a:p>
             <a:pPr algn="ctr"/>
+            <a:endParaRPr/>
           </a:p>
         </p:txBody>
       </p:sp>
@@ -8687,7 +9217,7 @@
           <a:noFill/>
         </p:spPr>
         <p:txBody>
-          <a:bodyPr wrap="square" anchor="t" lIns="0" rIns="0" tIns="0" bIns="0">
+          <a:bodyPr wrap="square" lIns="0" tIns="0" rIns="0" bIns="0" anchor="t">
             <a:spAutoFit/>
           </a:bodyPr>
           <a:lstStyle/>
@@ -8722,7 +9252,7 @@
           <a:noFill/>
         </p:spPr>
         <p:txBody>
-          <a:bodyPr wrap="square" anchor="t" lIns="0" rIns="0" tIns="0" bIns="0">
+          <a:bodyPr wrap="square" lIns="0" tIns="0" rIns="0" bIns="0" anchor="t">
             <a:spAutoFit/>
           </a:bodyPr>
           <a:lstStyle/>
@@ -8757,7 +9287,7 @@
           <a:noFill/>
         </p:spPr>
         <p:txBody>
-          <a:bodyPr wrap="square" lIns="0" rIns="0" tIns="0" bIns="0">
+          <a:bodyPr wrap="square" lIns="0" tIns="0" rIns="0" bIns="0">
             <a:spAutoFit/>
           </a:bodyPr>
           <a:lstStyle/>
@@ -8892,6 +9422,7 @@
           <a:lstStyle/>
           <a:p>
             <a:pPr algn="ctr"/>
+            <a:endParaRPr/>
           </a:p>
         </p:txBody>
       </p:sp>
@@ -8936,6 +9467,7 @@
           <a:lstStyle/>
           <a:p>
             <a:pPr algn="ctr"/>
+            <a:endParaRPr/>
           </a:p>
         </p:txBody>
       </p:sp>
@@ -8956,7 +9488,7 @@
           <a:noFill/>
         </p:spPr>
         <p:txBody>
-          <a:bodyPr wrap="square" anchor="ctr" lIns="0" rIns="0" tIns="0" bIns="0">
+          <a:bodyPr wrap="square" lIns="0" tIns="0" rIns="0" bIns="0" anchor="ctr">
             <a:spAutoFit/>
           </a:bodyPr>
           <a:lstStyle/>
@@ -8987,7 +9519,7 @@
 </file>
 
 <file path=ppt/slides/slide3.xml><?xml version="1.0" encoding="utf-8"?>
-<p:sld xmlns:a="http://schemas.openxmlformats.org/drawingml/2006/main" xmlns:p="http://schemas.openxmlformats.org/presentationml/2006/main" xmlns:r="http://schemas.openxmlformats.org/officeDocument/2006/relationships">
+<p:sld xmlns:a="http://schemas.openxmlformats.org/drawingml/2006/main" xmlns:r="http://schemas.openxmlformats.org/officeDocument/2006/relationships" xmlns:p="http://schemas.openxmlformats.org/presentationml/2006/main">
   <p:cSld>
     <p:bg>
       <p:bgPr>
@@ -9003,7 +9535,14 @@
         <p:cNvGrpSpPr/>
         <p:nvPr/>
       </p:nvGrpSpPr>
-      <p:grpSpPr/>
+      <p:grpSpPr>
+        <a:xfrm>
+          <a:off x="0" y="0"/>
+          <a:ext cx="0" cy="0"/>
+          <a:chOff x="0" y="0"/>
+          <a:chExt cx="0" cy="0"/>
+        </a:xfrm>
+      </p:grpSpPr>
       <p:sp>
         <p:nvSpPr>
           <p:cNvPr id="2" name="TextBox 1"/>
@@ -9021,7 +9560,7 @@
           <a:noFill/>
         </p:spPr>
         <p:txBody>
-          <a:bodyPr wrap="square" anchor="t" lIns="0" rIns="0" tIns="0" bIns="0">
+          <a:bodyPr wrap="square" lIns="0" tIns="0" rIns="0" bIns="0" anchor="t">
             <a:spAutoFit/>
           </a:bodyPr>
           <a:lstStyle/>
@@ -9080,7 +9619,7 @@
           </a:fontRef>
         </p:style>
         <p:txBody>
-          <a:bodyPr rtlCol="0" anchor="ctr" wrap="none"/>
+          <a:bodyPr wrap="none" rtlCol="0" anchor="ctr"/>
           <a:lstStyle/>
           <a:p>
             <a:pPr algn="ctr"/>
@@ -9122,7 +9661,7 @@
           <a:noFill/>
         </p:spPr>
         <p:txBody>
-          <a:bodyPr wrap="square" anchor="t" lIns="0" rIns="0" tIns="0" bIns="0">
+          <a:bodyPr wrap="square" lIns="0" tIns="0" rIns="0" bIns="0" anchor="t">
             <a:spAutoFit/>
           </a:bodyPr>
           <a:lstStyle/>
@@ -9185,6 +9724,7 @@
           <a:lstStyle/>
           <a:p>
             <a:pPr algn="ctr"/>
+            <a:endParaRPr/>
           </a:p>
         </p:txBody>
       </p:sp>
@@ -9229,6 +9769,7 @@
           <a:lstStyle/>
           <a:p>
             <a:pPr algn="ctr"/>
+            <a:endParaRPr/>
           </a:p>
         </p:txBody>
       </p:sp>
@@ -9249,7 +9790,7 @@
           <a:noFill/>
         </p:spPr>
         <p:txBody>
-          <a:bodyPr wrap="square" anchor="t" lIns="0" rIns="0" tIns="0" bIns="0">
+          <a:bodyPr wrap="square" lIns="0" tIns="0" rIns="0" bIns="0" anchor="t">
             <a:spAutoFit/>
           </a:bodyPr>
           <a:lstStyle/>
@@ -9284,7 +9825,7 @@
           <a:noFill/>
         </p:spPr>
         <p:txBody>
-          <a:bodyPr wrap="square" anchor="t" lIns="0" rIns="0" tIns="0" bIns="0">
+          <a:bodyPr wrap="square" lIns="0" tIns="0" rIns="0" bIns="0" anchor="t">
             <a:spAutoFit/>
           </a:bodyPr>
           <a:lstStyle/>
@@ -9347,6 +9888,7 @@
           <a:lstStyle/>
           <a:p>
             <a:pPr algn="ctr"/>
+            <a:endParaRPr/>
           </a:p>
         </p:txBody>
       </p:sp>
@@ -9391,6 +9933,7 @@
           <a:lstStyle/>
           <a:p>
             <a:pPr algn="ctr"/>
+            <a:endParaRPr/>
           </a:p>
         </p:txBody>
       </p:sp>
@@ -9411,7 +9954,7 @@
           <a:noFill/>
         </p:spPr>
         <p:txBody>
-          <a:bodyPr wrap="square" anchor="t" lIns="0" rIns="0" tIns="0" bIns="0">
+          <a:bodyPr wrap="square" lIns="0" tIns="0" rIns="0" bIns="0" anchor="t">
             <a:spAutoFit/>
           </a:bodyPr>
           <a:lstStyle/>
@@ -9446,7 +9989,7 @@
           <a:noFill/>
         </p:spPr>
         <p:txBody>
-          <a:bodyPr wrap="square" anchor="t" lIns="0" rIns="0" tIns="0" bIns="0">
+          <a:bodyPr wrap="square" lIns="0" tIns="0" rIns="0" bIns="0" anchor="t">
             <a:spAutoFit/>
           </a:bodyPr>
           <a:lstStyle/>
@@ -9513,6 +10056,7 @@
           <a:lstStyle/>
           <a:p>
             <a:pPr algn="ctr"/>
+            <a:endParaRPr/>
           </a:p>
         </p:txBody>
       </p:sp>
@@ -9557,6 +10101,7 @@
           <a:lstStyle/>
           <a:p>
             <a:pPr algn="ctr"/>
+            <a:endParaRPr/>
           </a:p>
         </p:txBody>
       </p:sp>
@@ -9577,7 +10122,7 @@
           <a:noFill/>
         </p:spPr>
         <p:txBody>
-          <a:bodyPr wrap="square" anchor="t" lIns="0" rIns="0" tIns="0" bIns="0">
+          <a:bodyPr wrap="square" lIns="0" tIns="0" rIns="0" bIns="0" anchor="t">
             <a:spAutoFit/>
           </a:bodyPr>
           <a:lstStyle/>
@@ -9612,7 +10157,7 @@
           <a:noFill/>
         </p:spPr>
         <p:txBody>
-          <a:bodyPr wrap="square" anchor="t" lIns="0" rIns="0" tIns="0" bIns="0">
+          <a:bodyPr wrap="square" lIns="0" tIns="0" rIns="0" bIns="0" anchor="t">
             <a:spAutoFit/>
           </a:bodyPr>
           <a:lstStyle/>
@@ -9679,6 +10224,7 @@
           <a:lstStyle/>
           <a:p>
             <a:pPr algn="ctr"/>
+            <a:endParaRPr/>
           </a:p>
         </p:txBody>
       </p:sp>
@@ -9723,6 +10269,7 @@
           <a:lstStyle/>
           <a:p>
             <a:pPr algn="ctr"/>
+            <a:endParaRPr/>
           </a:p>
         </p:txBody>
       </p:sp>
@@ -9743,7 +10290,7 @@
           <a:noFill/>
         </p:spPr>
         <p:txBody>
-          <a:bodyPr wrap="square" anchor="t" lIns="0" rIns="0" tIns="0" bIns="0">
+          <a:bodyPr wrap="square" lIns="0" tIns="0" rIns="0" bIns="0" anchor="t">
             <a:spAutoFit/>
           </a:bodyPr>
           <a:lstStyle/>
@@ -9778,7 +10325,7 @@
           <a:noFill/>
         </p:spPr>
         <p:txBody>
-          <a:bodyPr wrap="square" anchor="t" lIns="0" rIns="0" tIns="0" bIns="0">
+          <a:bodyPr wrap="square" lIns="0" tIns="0" rIns="0" bIns="0" anchor="t">
             <a:spAutoFit/>
           </a:bodyPr>
           <a:lstStyle/>
@@ -9817,7 +10364,7 @@
           <a:noFill/>
         </p:spPr>
         <p:txBody>
-          <a:bodyPr wrap="square" anchor="t" lIns="0" rIns="0" tIns="0" bIns="0">
+          <a:bodyPr wrap="square" lIns="0" tIns="0" rIns="0" bIns="0" anchor="t">
             <a:spAutoFit/>
           </a:bodyPr>
           <a:lstStyle/>
@@ -9852,7 +10399,7 @@
           <a:noFill/>
         </p:spPr>
         <p:txBody>
-          <a:bodyPr wrap="square" lIns="0" rIns="0" tIns="0" bIns="0">
+          <a:bodyPr wrap="square" lIns="0" tIns="0" rIns="0" bIns="0">
             <a:spAutoFit/>
           </a:bodyPr>
           <a:lstStyle/>
@@ -9881,7 +10428,7 @@
                 </a:solidFill>
                 <a:latin typeface="Arial"/>
               </a:rPr>
-              <a:t>Capacity names counties in text while need uses FIPS codes, and names lie.</a:t>
+              <a:t>Capacity names counties in text while need uses FIPS codes, and text names are an unreliable key: spellings and suffixes vary and names repeat across states.</a:t>
             </a:r>
           </a:p>
           <a:p>
@@ -9951,7 +10498,7 @@
 </file>
 
 <file path=ppt/slides/slide4.xml><?xml version="1.0" encoding="utf-8"?>
-<p:sld xmlns:a="http://schemas.openxmlformats.org/drawingml/2006/main" xmlns:p="http://schemas.openxmlformats.org/presentationml/2006/main" xmlns:r="http://schemas.openxmlformats.org/officeDocument/2006/relationships">
+<p:sld xmlns:a="http://schemas.openxmlformats.org/drawingml/2006/main" xmlns:r="http://schemas.openxmlformats.org/officeDocument/2006/relationships" xmlns:p="http://schemas.openxmlformats.org/presentationml/2006/main">
   <p:cSld>
     <p:bg>
       <p:bgPr>
@@ -9967,7 +10514,14 @@
         <p:cNvGrpSpPr/>
         <p:nvPr/>
       </p:nvGrpSpPr>
-      <p:grpSpPr/>
+      <p:grpSpPr>
+        <a:xfrm>
+          <a:off x="0" y="0"/>
+          <a:ext cx="0" cy="0"/>
+          <a:chOff x="0" y="0"/>
+          <a:chExt cx="0" cy="0"/>
+        </a:xfrm>
+      </p:grpSpPr>
       <p:sp>
         <p:nvSpPr>
           <p:cNvPr id="2" name="TextBox 1"/>
@@ -9985,7 +10539,7 @@
           <a:noFill/>
         </p:spPr>
         <p:txBody>
-          <a:bodyPr wrap="square" anchor="t" lIns="0" rIns="0" tIns="0" bIns="0">
+          <a:bodyPr wrap="square" lIns="0" tIns="0" rIns="0" bIns="0" anchor="t">
             <a:spAutoFit/>
           </a:bodyPr>
           <a:lstStyle/>
@@ -10044,7 +10598,7 @@
           </a:fontRef>
         </p:style>
         <p:txBody>
-          <a:bodyPr rtlCol="0" anchor="ctr" wrap="none"/>
+          <a:bodyPr wrap="none" rtlCol="0" anchor="ctr"/>
           <a:lstStyle/>
           <a:p>
             <a:pPr algn="ctr"/>
@@ -10086,7 +10640,7 @@
           <a:noFill/>
         </p:spPr>
         <p:txBody>
-          <a:bodyPr wrap="square" anchor="t" lIns="0" rIns="0" tIns="0" bIns="0">
+          <a:bodyPr wrap="square" lIns="0" tIns="0" rIns="0" bIns="0" anchor="t">
             <a:spAutoFit/>
           </a:bodyPr>
           <a:lstStyle/>
@@ -10149,6 +10703,7 @@
           <a:lstStyle/>
           <a:p>
             <a:pPr algn="ctr"/>
+            <a:endParaRPr/>
           </a:p>
         </p:txBody>
       </p:sp>
@@ -10193,6 +10748,7 @@
           <a:lstStyle/>
           <a:p>
             <a:pPr algn="ctr"/>
+            <a:endParaRPr/>
           </a:p>
         </p:txBody>
       </p:sp>
@@ -10213,7 +10769,7 @@
           <a:noFill/>
         </p:spPr>
         <p:txBody>
-          <a:bodyPr wrap="square" anchor="t" lIns="0" rIns="0" tIns="0" bIns="0">
+          <a:bodyPr wrap="square" lIns="0" tIns="0" rIns="0" bIns="0" anchor="t">
             <a:spAutoFit/>
           </a:bodyPr>
           <a:lstStyle/>
@@ -10248,7 +10804,7 @@
           <a:noFill/>
         </p:spPr>
         <p:txBody>
-          <a:bodyPr wrap="square" anchor="t" lIns="0" rIns="0" tIns="0" bIns="0">
+          <a:bodyPr wrap="square" lIns="0" tIns="0" rIns="0" bIns="0" anchor="t">
             <a:spAutoFit/>
           </a:bodyPr>
           <a:lstStyle/>
@@ -10311,6 +10867,7 @@
           <a:lstStyle/>
           <a:p>
             <a:pPr algn="ctr"/>
+            <a:endParaRPr/>
           </a:p>
         </p:txBody>
       </p:sp>
@@ -10355,6 +10912,7 @@
           <a:lstStyle/>
           <a:p>
             <a:pPr algn="ctr"/>
+            <a:endParaRPr/>
           </a:p>
         </p:txBody>
       </p:sp>
@@ -10375,7 +10933,7 @@
           <a:noFill/>
         </p:spPr>
         <p:txBody>
-          <a:bodyPr wrap="square" anchor="t" lIns="0" rIns="0" tIns="0" bIns="0">
+          <a:bodyPr wrap="square" lIns="0" tIns="0" rIns="0" bIns="0" anchor="t">
             <a:spAutoFit/>
           </a:bodyPr>
           <a:lstStyle/>
@@ -10410,7 +10968,7 @@
           <a:noFill/>
         </p:spPr>
         <p:txBody>
-          <a:bodyPr wrap="square" anchor="t" lIns="0" rIns="0" tIns="0" bIns="0">
+          <a:bodyPr wrap="square" lIns="0" tIns="0" rIns="0" bIns="0" anchor="t">
             <a:spAutoFit/>
           </a:bodyPr>
           <a:lstStyle/>
@@ -10445,7 +11003,7 @@
           <a:noFill/>
         </p:spPr>
         <p:txBody>
-          <a:bodyPr wrap="square" anchor="t" lIns="0" rIns="0" tIns="0" bIns="0">
+          <a:bodyPr wrap="square" lIns="0" tIns="0" rIns="0" bIns="0" anchor="t">
             <a:spAutoFit/>
           </a:bodyPr>
           <a:lstStyle/>
@@ -10512,6 +11070,7 @@
           <a:lstStyle/>
           <a:p>
             <a:pPr algn="ctr"/>
+            <a:endParaRPr/>
           </a:p>
         </p:txBody>
       </p:sp>
@@ -10556,6 +11115,7 @@
           <a:lstStyle/>
           <a:p>
             <a:pPr algn="ctr"/>
+            <a:endParaRPr/>
           </a:p>
         </p:txBody>
       </p:sp>
@@ -10576,7 +11136,7 @@
           <a:noFill/>
         </p:spPr>
         <p:txBody>
-          <a:bodyPr wrap="square" anchor="t" lIns="0" rIns="0" tIns="0" bIns="0">
+          <a:bodyPr wrap="square" lIns="0" tIns="0" rIns="0" bIns="0" anchor="t">
             <a:spAutoFit/>
           </a:bodyPr>
           <a:lstStyle/>
@@ -10611,7 +11171,7 @@
           <a:noFill/>
         </p:spPr>
         <p:txBody>
-          <a:bodyPr wrap="square" anchor="t" lIns="0" rIns="0" tIns="0" bIns="0">
+          <a:bodyPr wrap="square" lIns="0" tIns="0" rIns="0" bIns="0" anchor="t">
             <a:spAutoFit/>
           </a:bodyPr>
           <a:lstStyle/>
@@ -10646,7 +11206,7 @@
           <a:noFill/>
         </p:spPr>
         <p:txBody>
-          <a:bodyPr wrap="square" anchor="t" lIns="0" rIns="0" tIns="0" bIns="0">
+          <a:bodyPr wrap="square" lIns="0" tIns="0" rIns="0" bIns="0" anchor="t">
             <a:spAutoFit/>
           </a:bodyPr>
           <a:lstStyle/>
@@ -10713,6 +11273,7 @@
           <a:lstStyle/>
           <a:p>
             <a:pPr algn="ctr"/>
+            <a:endParaRPr/>
           </a:p>
         </p:txBody>
       </p:sp>
@@ -10757,6 +11318,7 @@
           <a:lstStyle/>
           <a:p>
             <a:pPr algn="ctr"/>
+            <a:endParaRPr/>
           </a:p>
         </p:txBody>
       </p:sp>
@@ -10777,7 +11339,7 @@
           <a:noFill/>
         </p:spPr>
         <p:txBody>
-          <a:bodyPr wrap="square" anchor="t" lIns="0" rIns="0" tIns="0" bIns="0">
+          <a:bodyPr wrap="square" lIns="0" tIns="0" rIns="0" bIns="0" anchor="t">
             <a:spAutoFit/>
           </a:bodyPr>
           <a:lstStyle/>
@@ -10812,7 +11374,7 @@
           <a:noFill/>
         </p:spPr>
         <p:txBody>
-          <a:bodyPr wrap="square" anchor="t" lIns="0" rIns="0" tIns="0" bIns="0">
+          <a:bodyPr wrap="square" lIns="0" tIns="0" rIns="0" bIns="0" anchor="t">
             <a:spAutoFit/>
           </a:bodyPr>
           <a:lstStyle/>
@@ -10847,7 +11409,7 @@
           <a:noFill/>
         </p:spPr>
         <p:txBody>
-          <a:bodyPr wrap="square" anchor="t" lIns="0" rIns="0" tIns="0" bIns="0">
+          <a:bodyPr wrap="square" lIns="0" tIns="0" rIns="0" bIns="0" anchor="t">
             <a:spAutoFit/>
           </a:bodyPr>
           <a:lstStyle/>
@@ -10886,7 +11448,7 @@
           <a:noFill/>
         </p:spPr>
         <p:txBody>
-          <a:bodyPr wrap="square" anchor="t" lIns="0" rIns="0" tIns="0" bIns="0">
+          <a:bodyPr wrap="square" lIns="0" tIns="0" rIns="0" bIns="0" anchor="t">
             <a:spAutoFit/>
           </a:bodyPr>
           <a:lstStyle/>
@@ -10922,7 +11484,7 @@
 </file>
 
 <file path=ppt/slides/slide5.xml><?xml version="1.0" encoding="utf-8"?>
-<p:sld xmlns:a="http://schemas.openxmlformats.org/drawingml/2006/main" xmlns:p="http://schemas.openxmlformats.org/presentationml/2006/main" xmlns:r="http://schemas.openxmlformats.org/officeDocument/2006/relationships">
+<p:sld xmlns:a="http://schemas.openxmlformats.org/drawingml/2006/main" xmlns:r="http://schemas.openxmlformats.org/officeDocument/2006/relationships" xmlns:p="http://schemas.openxmlformats.org/presentationml/2006/main">
   <p:cSld>
     <p:bg>
       <p:bgPr>
@@ -10938,7 +11500,14 @@
         <p:cNvGrpSpPr/>
         <p:nvPr/>
       </p:nvGrpSpPr>
-      <p:grpSpPr/>
+      <p:grpSpPr>
+        <a:xfrm>
+          <a:off x="0" y="0"/>
+          <a:ext cx="0" cy="0"/>
+          <a:chOff x="0" y="0"/>
+          <a:chExt cx="0" cy="0"/>
+        </a:xfrm>
+      </p:grpSpPr>
       <p:sp>
         <p:nvSpPr>
           <p:cNvPr id="2" name="TextBox 1"/>
@@ -10956,7 +11525,7 @@
           <a:noFill/>
         </p:spPr>
         <p:txBody>
-          <a:bodyPr wrap="square" anchor="t" lIns="0" rIns="0" tIns="0" bIns="0">
+          <a:bodyPr wrap="square" lIns="0" tIns="0" rIns="0" bIns="0" anchor="t">
             <a:spAutoFit/>
           </a:bodyPr>
           <a:lstStyle/>
@@ -11015,7 +11584,7 @@
           </a:fontRef>
         </p:style>
         <p:txBody>
-          <a:bodyPr rtlCol="0" anchor="ctr" wrap="none"/>
+          <a:bodyPr wrap="none" rtlCol="0" anchor="ctr"/>
           <a:lstStyle/>
           <a:p>
             <a:pPr algn="ctr"/>
@@ -11057,7 +11626,7 @@
           <a:noFill/>
         </p:spPr>
         <p:txBody>
-          <a:bodyPr wrap="square" anchor="t" lIns="0" rIns="0" tIns="0" bIns="0">
+          <a:bodyPr wrap="square" lIns="0" tIns="0" rIns="0" bIns="0" anchor="t">
             <a:spAutoFit/>
           </a:bodyPr>
           <a:lstStyle/>
@@ -11120,6 +11689,7 @@
           <a:lstStyle/>
           <a:p>
             <a:pPr algn="ctr"/>
+            <a:endParaRPr/>
           </a:p>
         </p:txBody>
       </p:sp>
@@ -11164,6 +11734,7 @@
           <a:lstStyle/>
           <a:p>
             <a:pPr algn="ctr"/>
+            <a:endParaRPr/>
           </a:p>
         </p:txBody>
       </p:sp>
@@ -11184,7 +11755,7 @@
           <a:noFill/>
         </p:spPr>
         <p:txBody>
-          <a:bodyPr wrap="square" anchor="t" lIns="0" rIns="0" tIns="0" bIns="0">
+          <a:bodyPr wrap="square" lIns="0" tIns="0" rIns="0" bIns="0" anchor="t">
             <a:spAutoFit/>
           </a:bodyPr>
           <a:lstStyle/>
@@ -11219,7 +11790,7 @@
           <a:noFill/>
         </p:spPr>
         <p:txBody>
-          <a:bodyPr wrap="square" anchor="t" lIns="0" rIns="0" tIns="0" bIns="0">
+          <a:bodyPr wrap="square" lIns="0" tIns="0" rIns="0" bIns="0" anchor="t">
             <a:spAutoFit/>
           </a:bodyPr>
           <a:lstStyle/>
@@ -11282,6 +11853,7 @@
           <a:lstStyle/>
           <a:p>
             <a:pPr algn="ctr"/>
+            <a:endParaRPr/>
           </a:p>
         </p:txBody>
       </p:sp>
@@ -11326,6 +11898,7 @@
           <a:lstStyle/>
           <a:p>
             <a:pPr algn="ctr"/>
+            <a:endParaRPr/>
           </a:p>
         </p:txBody>
       </p:sp>
@@ -11346,7 +11919,7 @@
           <a:noFill/>
         </p:spPr>
         <p:txBody>
-          <a:bodyPr wrap="square" anchor="t" lIns="0" rIns="0" tIns="0" bIns="0">
+          <a:bodyPr wrap="square" lIns="0" tIns="0" rIns="0" bIns="0" anchor="t">
             <a:spAutoFit/>
           </a:bodyPr>
           <a:lstStyle/>
@@ -11381,7 +11954,7 @@
           <a:noFill/>
         </p:spPr>
         <p:txBody>
-          <a:bodyPr wrap="square" anchor="t" lIns="0" rIns="0" tIns="0" bIns="0">
+          <a:bodyPr wrap="square" lIns="0" tIns="0" rIns="0" bIns="0" anchor="t">
             <a:spAutoFit/>
           </a:bodyPr>
           <a:lstStyle/>
@@ -11448,6 +12021,7 @@
           <a:lstStyle/>
           <a:p>
             <a:pPr algn="ctr"/>
+            <a:endParaRPr/>
           </a:p>
         </p:txBody>
       </p:sp>
@@ -11492,6 +12066,7 @@
           <a:lstStyle/>
           <a:p>
             <a:pPr algn="ctr"/>
+            <a:endParaRPr/>
           </a:p>
         </p:txBody>
       </p:sp>
@@ -11512,7 +12087,7 @@
           <a:noFill/>
         </p:spPr>
         <p:txBody>
-          <a:bodyPr wrap="square" anchor="t" lIns="0" rIns="0" tIns="0" bIns="0">
+          <a:bodyPr wrap="square" lIns="0" tIns="0" rIns="0" bIns="0" anchor="t">
             <a:spAutoFit/>
           </a:bodyPr>
           <a:lstStyle/>
@@ -11547,7 +12122,7 @@
           <a:noFill/>
         </p:spPr>
         <p:txBody>
-          <a:bodyPr wrap="square" anchor="t" lIns="0" rIns="0" tIns="0" bIns="0">
+          <a:bodyPr wrap="square" lIns="0" tIns="0" rIns="0" bIns="0" anchor="t">
             <a:spAutoFit/>
           </a:bodyPr>
           <a:lstStyle/>
@@ -11614,6 +12189,7 @@
           <a:lstStyle/>
           <a:p>
             <a:pPr algn="ctr"/>
+            <a:endParaRPr/>
           </a:p>
         </p:txBody>
       </p:sp>
@@ -11658,6 +12234,7 @@
           <a:lstStyle/>
           <a:p>
             <a:pPr algn="ctr"/>
+            <a:endParaRPr/>
           </a:p>
         </p:txBody>
       </p:sp>
@@ -11678,7 +12255,7 @@
           <a:noFill/>
         </p:spPr>
         <p:txBody>
-          <a:bodyPr wrap="square" anchor="t" lIns="0" rIns="0" tIns="0" bIns="0">
+          <a:bodyPr wrap="square" lIns="0" tIns="0" rIns="0" bIns="0" anchor="t">
             <a:spAutoFit/>
           </a:bodyPr>
           <a:lstStyle/>
@@ -11713,7 +12290,7 @@
           <a:noFill/>
         </p:spPr>
         <p:txBody>
-          <a:bodyPr wrap="square" anchor="t" lIns="0" rIns="0" tIns="0" bIns="0">
+          <a:bodyPr wrap="square" lIns="0" tIns="0" rIns="0" bIns="0" anchor="t">
             <a:spAutoFit/>
           </a:bodyPr>
           <a:lstStyle/>
@@ -11752,7 +12329,7 @@
           <a:noFill/>
         </p:spPr>
         <p:txBody>
-          <a:bodyPr wrap="square" lIns="0" rIns="0" tIns="0" bIns="0">
+          <a:bodyPr wrap="square" lIns="0" tIns="0" rIns="0" bIns="0">
             <a:spAutoFit/>
           </a:bodyPr>
           <a:lstStyle/>
@@ -11851,7 +12428,7 @@
 </file>
 
 <file path=ppt/slides/slide6.xml><?xml version="1.0" encoding="utf-8"?>
-<p:sld xmlns:a="http://schemas.openxmlformats.org/drawingml/2006/main" xmlns:p="http://schemas.openxmlformats.org/presentationml/2006/main" xmlns:r="http://schemas.openxmlformats.org/officeDocument/2006/relationships">
+<p:sld xmlns:a="http://schemas.openxmlformats.org/drawingml/2006/main" xmlns:r="http://schemas.openxmlformats.org/officeDocument/2006/relationships" xmlns:p="http://schemas.openxmlformats.org/presentationml/2006/main">
   <p:cSld>
     <p:bg>
       <p:bgPr>
@@ -11867,7 +12444,14 @@
         <p:cNvGrpSpPr/>
         <p:nvPr/>
       </p:nvGrpSpPr>
-      <p:grpSpPr/>
+      <p:grpSpPr>
+        <a:xfrm>
+          <a:off x="0" y="0"/>
+          <a:ext cx="0" cy="0"/>
+          <a:chOff x="0" y="0"/>
+          <a:chExt cx="0" cy="0"/>
+        </a:xfrm>
+      </p:grpSpPr>
       <p:sp>
         <p:nvSpPr>
           <p:cNvPr id="2" name="TextBox 1"/>
@@ -11885,7 +12469,7 @@
           <a:noFill/>
         </p:spPr>
         <p:txBody>
-          <a:bodyPr wrap="square" anchor="t" lIns="0" rIns="0" tIns="0" bIns="0">
+          <a:bodyPr wrap="square" lIns="0" tIns="0" rIns="0" bIns="0" anchor="t">
             <a:spAutoFit/>
           </a:bodyPr>
           <a:lstStyle/>
@@ -11944,7 +12528,7 @@
           </a:fontRef>
         </p:style>
         <p:txBody>
-          <a:bodyPr rtlCol="0" anchor="ctr" wrap="none"/>
+          <a:bodyPr wrap="none" rtlCol="0" anchor="ctr"/>
           <a:lstStyle/>
           <a:p>
             <a:pPr algn="ctr"/>
@@ -11986,7 +12570,7 @@
           <a:noFill/>
         </p:spPr>
         <p:txBody>
-          <a:bodyPr wrap="square" anchor="t" lIns="0" rIns="0" tIns="0" bIns="0">
+          <a:bodyPr wrap="square" lIns="0" tIns="0" rIns="0" bIns="0" anchor="t">
             <a:spAutoFit/>
           </a:bodyPr>
           <a:lstStyle/>
@@ -12049,6 +12633,7 @@
           <a:lstStyle/>
           <a:p>
             <a:pPr algn="ctr"/>
+            <a:endParaRPr/>
           </a:p>
         </p:txBody>
       </p:sp>
@@ -12093,6 +12678,7 @@
           <a:lstStyle/>
           <a:p>
             <a:pPr algn="ctr"/>
+            <a:endParaRPr/>
           </a:p>
         </p:txBody>
       </p:sp>
@@ -12113,7 +12699,7 @@
           <a:noFill/>
         </p:spPr>
         <p:txBody>
-          <a:bodyPr wrap="square" anchor="t" lIns="0" rIns="0" tIns="0" bIns="0">
+          <a:bodyPr wrap="square" lIns="0" tIns="0" rIns="0" bIns="0" anchor="t">
             <a:spAutoFit/>
           </a:bodyPr>
           <a:lstStyle/>
@@ -12148,7 +12734,7 @@
           <a:noFill/>
         </p:spPr>
         <p:txBody>
-          <a:bodyPr wrap="square" anchor="t" lIns="0" rIns="0" tIns="0" bIns="0">
+          <a:bodyPr wrap="square" lIns="0" tIns="0" rIns="0" bIns="0" anchor="t">
             <a:spAutoFit/>
           </a:bodyPr>
           <a:lstStyle/>
@@ -12183,7 +12769,7 @@
           <a:noFill/>
         </p:spPr>
         <p:txBody>
-          <a:bodyPr wrap="square" lIns="0" rIns="0" tIns="0" bIns="0">
+          <a:bodyPr wrap="square" lIns="0" tIns="0" rIns="0" bIns="0">
             <a:spAutoFit/>
           </a:bodyPr>
           <a:lstStyle/>
@@ -12286,7 +12872,7 @@
           <a:noFill/>
         </p:spPr>
         <p:txBody>
-          <a:bodyPr wrap="square" anchor="t" lIns="0" rIns="0" tIns="0" bIns="0">
+          <a:bodyPr wrap="square" lIns="0" tIns="0" rIns="0" bIns="0" anchor="t">
             <a:spAutoFit/>
           </a:bodyPr>
           <a:lstStyle/>
@@ -12313,7 +12899,7 @@
 </file>
 
 <file path=ppt/slides/slide7.xml><?xml version="1.0" encoding="utf-8"?>
-<p:sld xmlns:a="http://schemas.openxmlformats.org/drawingml/2006/main" xmlns:p="http://schemas.openxmlformats.org/presentationml/2006/main" xmlns:r="http://schemas.openxmlformats.org/officeDocument/2006/relationships">
+<p:sld xmlns:a="http://schemas.openxmlformats.org/drawingml/2006/main" xmlns:r="http://schemas.openxmlformats.org/officeDocument/2006/relationships" xmlns:p="http://schemas.openxmlformats.org/presentationml/2006/main">
   <p:cSld>
     <p:bg>
       <p:bgPr>
@@ -12329,7 +12915,14 @@
         <p:cNvGrpSpPr/>
         <p:nvPr/>
       </p:nvGrpSpPr>
-      <p:grpSpPr/>
+      <p:grpSpPr>
+        <a:xfrm>
+          <a:off x="0" y="0"/>
+          <a:ext cx="0" cy="0"/>
+          <a:chOff x="0" y="0"/>
+          <a:chExt cx="0" cy="0"/>
+        </a:xfrm>
+      </p:grpSpPr>
       <p:sp>
         <p:nvSpPr>
           <p:cNvPr id="2" name="TextBox 1"/>
@@ -12347,7 +12940,7 @@
           <a:noFill/>
         </p:spPr>
         <p:txBody>
-          <a:bodyPr wrap="square" anchor="t" lIns="0" rIns="0" tIns="0" bIns="0">
+          <a:bodyPr wrap="square" lIns="0" tIns="0" rIns="0" bIns="0" anchor="t">
             <a:spAutoFit/>
           </a:bodyPr>
           <a:lstStyle/>
@@ -12406,7 +12999,7 @@
           </a:fontRef>
         </p:style>
         <p:txBody>
-          <a:bodyPr rtlCol="0" anchor="ctr" wrap="none"/>
+          <a:bodyPr wrap="none" rtlCol="0" anchor="ctr"/>
           <a:lstStyle/>
           <a:p>
             <a:pPr algn="ctr"/>
@@ -12448,7 +13041,7 @@
           <a:noFill/>
         </p:spPr>
         <p:txBody>
-          <a:bodyPr wrap="square" anchor="t" lIns="0" rIns="0" tIns="0" bIns="0">
+          <a:bodyPr wrap="square" lIns="0" tIns="0" rIns="0" bIns="0" anchor="t">
             <a:spAutoFit/>
           </a:bodyPr>
           <a:lstStyle/>
@@ -12511,6 +13104,7 @@
           <a:lstStyle/>
           <a:p>
             <a:pPr algn="ctr"/>
+            <a:endParaRPr/>
           </a:p>
         </p:txBody>
       </p:sp>
@@ -12555,6 +13149,7 @@
           <a:lstStyle/>
           <a:p>
             <a:pPr algn="ctr"/>
+            <a:endParaRPr/>
           </a:p>
         </p:txBody>
       </p:sp>
@@ -12575,7 +13170,7 @@
           <a:noFill/>
         </p:spPr>
         <p:txBody>
-          <a:bodyPr wrap="square" anchor="t" lIns="0" rIns="0" tIns="0" bIns="0">
+          <a:bodyPr wrap="square" lIns="0" tIns="0" rIns="0" bIns="0" anchor="t">
             <a:spAutoFit/>
           </a:bodyPr>
           <a:lstStyle/>
@@ -12610,7 +13205,7 @@
           <a:noFill/>
         </p:spPr>
         <p:txBody>
-          <a:bodyPr wrap="square" anchor="t" lIns="0" rIns="0" tIns="0" bIns="0">
+          <a:bodyPr wrap="square" lIns="0" tIns="0" rIns="0" bIns="0" anchor="t">
             <a:spAutoFit/>
           </a:bodyPr>
           <a:lstStyle/>
@@ -12669,7 +13264,7 @@
           <a:noFill/>
         </p:spPr>
         <p:txBody>
-          <a:bodyPr wrap="square" anchor="t" lIns="0" rIns="0" tIns="0" bIns="0">
+          <a:bodyPr wrap="square" lIns="0" tIns="0" rIns="0" bIns="0" anchor="t">
             <a:spAutoFit/>
           </a:bodyPr>
           <a:lstStyle/>
@@ -12696,7 +13291,7 @@
 </file>
 
 <file path=ppt/slides/slide8.xml><?xml version="1.0" encoding="utf-8"?>
-<p:sld xmlns:a="http://schemas.openxmlformats.org/drawingml/2006/main" xmlns:p="http://schemas.openxmlformats.org/presentationml/2006/main" xmlns:r="http://schemas.openxmlformats.org/officeDocument/2006/relationships">
+<p:sld xmlns:a="http://schemas.openxmlformats.org/drawingml/2006/main" xmlns:r="http://schemas.openxmlformats.org/officeDocument/2006/relationships" xmlns:p="http://schemas.openxmlformats.org/presentationml/2006/main">
   <p:cSld>
     <p:bg>
       <p:bgPr>
@@ -12712,7 +13307,14 @@
         <p:cNvGrpSpPr/>
         <p:nvPr/>
       </p:nvGrpSpPr>
-      <p:grpSpPr/>
+      <p:grpSpPr>
+        <a:xfrm>
+          <a:off x="0" y="0"/>
+          <a:ext cx="0" cy="0"/>
+          <a:chOff x="0" y="0"/>
+          <a:chExt cx="0" cy="0"/>
+        </a:xfrm>
+      </p:grpSpPr>
       <p:sp>
         <p:nvSpPr>
           <p:cNvPr id="2" name="TextBox 1"/>
@@ -12730,7 +13332,7 @@
           <a:noFill/>
         </p:spPr>
         <p:txBody>
-          <a:bodyPr wrap="square" anchor="t" lIns="0" rIns="0" tIns="0" bIns="0">
+          <a:bodyPr wrap="square" lIns="0" tIns="0" rIns="0" bIns="0" anchor="t">
             <a:spAutoFit/>
           </a:bodyPr>
           <a:lstStyle/>
@@ -12789,7 +13391,7 @@
           </a:fontRef>
         </p:style>
         <p:txBody>
-          <a:bodyPr rtlCol="0" anchor="ctr" wrap="none"/>
+          <a:bodyPr wrap="none" rtlCol="0" anchor="ctr"/>
           <a:lstStyle/>
           <a:p>
             <a:pPr algn="ctr"/>
@@ -12831,7 +13433,7 @@
           <a:noFill/>
         </p:spPr>
         <p:txBody>
-          <a:bodyPr wrap="square" anchor="t" lIns="0" rIns="0" tIns="0" bIns="0">
+          <a:bodyPr wrap="square" lIns="0" tIns="0" rIns="0" bIns="0" anchor="t">
             <a:spAutoFit/>
           </a:bodyPr>
           <a:lstStyle/>
@@ -12894,6 +13496,7 @@
           <a:lstStyle/>
           <a:p>
             <a:pPr algn="ctr"/>
+            <a:endParaRPr/>
           </a:p>
         </p:txBody>
       </p:sp>
@@ -12938,6 +13541,7 @@
           <a:lstStyle/>
           <a:p>
             <a:pPr algn="ctr"/>
+            <a:endParaRPr/>
           </a:p>
         </p:txBody>
       </p:sp>
@@ -12958,7 +13562,7 @@
           <a:noFill/>
         </p:spPr>
         <p:txBody>
-          <a:bodyPr wrap="square" anchor="t" lIns="0" rIns="0" tIns="0" bIns="0">
+          <a:bodyPr wrap="square" lIns="0" tIns="0" rIns="0" bIns="0" anchor="t">
             <a:spAutoFit/>
           </a:bodyPr>
           <a:lstStyle/>
@@ -12993,7 +13597,7 @@
           <a:noFill/>
         </p:spPr>
         <p:txBody>
-          <a:bodyPr wrap="square" anchor="t" lIns="0" rIns="0" tIns="0" bIns="0">
+          <a:bodyPr wrap="square" lIns="0" tIns="0" rIns="0" bIns="0" anchor="t">
             <a:spAutoFit/>
           </a:bodyPr>
           <a:lstStyle/>
@@ -13052,7 +13656,7 @@
           <a:noFill/>
         </p:spPr>
         <p:txBody>
-          <a:bodyPr wrap="square" anchor="t" lIns="0" rIns="0" tIns="0" bIns="0">
+          <a:bodyPr wrap="square" lIns="0" tIns="0" rIns="0" bIns="0" anchor="t">
             <a:spAutoFit/>
           </a:bodyPr>
           <a:lstStyle/>
@@ -13079,7 +13683,7 @@
 </file>
 
 <file path=ppt/slides/slide9.xml><?xml version="1.0" encoding="utf-8"?>
-<p:sld xmlns:a="http://schemas.openxmlformats.org/drawingml/2006/main" xmlns:p="http://schemas.openxmlformats.org/presentationml/2006/main" xmlns:r="http://schemas.openxmlformats.org/officeDocument/2006/relationships">
+<p:sld xmlns:a="http://schemas.openxmlformats.org/drawingml/2006/main" xmlns:r="http://schemas.openxmlformats.org/officeDocument/2006/relationships" xmlns:p="http://schemas.openxmlformats.org/presentationml/2006/main">
   <p:cSld>
     <p:bg>
       <p:bgPr>
@@ -13095,7 +13699,14 @@
         <p:cNvGrpSpPr/>
         <p:nvPr/>
       </p:nvGrpSpPr>
-      <p:grpSpPr/>
+      <p:grpSpPr>
+        <a:xfrm>
+          <a:off x="0" y="0"/>
+          <a:ext cx="0" cy="0"/>
+          <a:chOff x="0" y="0"/>
+          <a:chExt cx="0" cy="0"/>
+        </a:xfrm>
+      </p:grpSpPr>
       <p:sp>
         <p:nvSpPr>
           <p:cNvPr id="2" name="TextBox 1"/>
@@ -13113,7 +13724,7 @@
           <a:noFill/>
         </p:spPr>
         <p:txBody>
-          <a:bodyPr wrap="square" anchor="t" lIns="0" rIns="0" tIns="0" bIns="0">
+          <a:bodyPr wrap="square" lIns="0" tIns="0" rIns="0" bIns="0" anchor="t">
             <a:spAutoFit/>
           </a:bodyPr>
           <a:lstStyle/>
@@ -13172,7 +13783,7 @@
           </a:fontRef>
         </p:style>
         <p:txBody>
-          <a:bodyPr rtlCol="0" anchor="ctr" wrap="none"/>
+          <a:bodyPr wrap="none" rtlCol="0" anchor="ctr"/>
           <a:lstStyle/>
           <a:p>
             <a:pPr algn="ctr"/>
@@ -13214,7 +13825,7 @@
           <a:noFill/>
         </p:spPr>
         <p:txBody>
-          <a:bodyPr wrap="square" anchor="t" lIns="0" rIns="0" tIns="0" bIns="0">
+          <a:bodyPr wrap="square" lIns="0" tIns="0" rIns="0" bIns="0" anchor="t">
             <a:spAutoFit/>
           </a:bodyPr>
           <a:lstStyle/>
@@ -13277,6 +13888,7 @@
           <a:lstStyle/>
           <a:p>
             <a:pPr algn="ctr"/>
+            <a:endParaRPr/>
           </a:p>
         </p:txBody>
       </p:sp>
@@ -13321,6 +13933,7 @@
           <a:lstStyle/>
           <a:p>
             <a:pPr algn="ctr"/>
+            <a:endParaRPr/>
           </a:p>
         </p:txBody>
       </p:sp>
@@ -13341,7 +13954,7 @@
           <a:noFill/>
         </p:spPr>
         <p:txBody>
-          <a:bodyPr wrap="square" anchor="t" lIns="0" rIns="0" tIns="0" bIns="0">
+          <a:bodyPr wrap="square" lIns="0" tIns="0" rIns="0" bIns="0" anchor="t">
             <a:spAutoFit/>
           </a:bodyPr>
           <a:lstStyle/>
@@ -13376,7 +13989,7 @@
           <a:noFill/>
         </p:spPr>
         <p:txBody>
-          <a:bodyPr wrap="square" anchor="t" lIns="0" rIns="0" tIns="0" bIns="0">
+          <a:bodyPr wrap="square" lIns="0" tIns="0" rIns="0" bIns="0" anchor="t">
             <a:spAutoFit/>
           </a:bodyPr>
           <a:lstStyle/>
@@ -13411,7 +14024,7 @@
           <a:noFill/>
         </p:spPr>
         <p:txBody>
-          <a:bodyPr wrap="square" lIns="0" rIns="0" tIns="0" bIns="0">
+          <a:bodyPr wrap="square" lIns="0" tIns="0" rIns="0" bIns="0">
             <a:spAutoFit/>
           </a:bodyPr>
           <a:lstStyle/>
@@ -13514,7 +14127,7 @@
           <a:noFill/>
         </p:spPr>
         <p:txBody>
-          <a:bodyPr wrap="square" anchor="t" lIns="0" rIns="0" tIns="0" bIns="0">
+          <a:bodyPr wrap="square" lIns="0" tIns="0" rIns="0" bIns="0" anchor="t">
             <a:spAutoFit/>
           </a:bodyPr>
           <a:lstStyle/>
@@ -13858,4 +14471,319 @@
   </a:objectDefaults>
   <a:extraClrSchemeLst/>
 </a:theme>
+</file>
+
+<file path=ppt/theme/theme2.xml><?xml version="1.0" encoding="utf-8"?>
+<a:theme xmlns:a="http://schemas.openxmlformats.org/drawingml/2006/main" name="Office Theme">
+  <a:themeElements>
+    <a:clrScheme name="Office">
+      <a:dk1>
+        <a:sysClr val="windowText" lastClr="000000"/>
+      </a:dk1>
+      <a:lt1>
+        <a:sysClr val="window" lastClr="FFFFFF"/>
+      </a:lt1>
+      <a:dk2>
+        <a:srgbClr val="0E2841"/>
+      </a:dk2>
+      <a:lt2>
+        <a:srgbClr val="E8E8E8"/>
+      </a:lt2>
+      <a:accent1>
+        <a:srgbClr val="156082"/>
+      </a:accent1>
+      <a:accent2>
+        <a:srgbClr val="E97132"/>
+      </a:accent2>
+      <a:accent3>
+        <a:srgbClr val="196B24"/>
+      </a:accent3>
+      <a:accent4>
+        <a:srgbClr val="0F9ED5"/>
+      </a:accent4>
+      <a:accent5>
+        <a:srgbClr val="A02B93"/>
+      </a:accent5>
+      <a:accent6>
+        <a:srgbClr val="4EA72E"/>
+      </a:accent6>
+      <a:hlink>
+        <a:srgbClr val="467886"/>
+      </a:hlink>
+      <a:folHlink>
+        <a:srgbClr val="96607D"/>
+      </a:folHlink>
+    </a:clrScheme>
+    <a:fontScheme name="Office">
+      <a:majorFont>
+        <a:latin typeface="Aptos Display" panose="02110004020202020204"/>
+        <a:ea typeface=""/>
+        <a:cs typeface=""/>
+        <a:font script="Jpan" typeface="游ゴシック Light"/>
+        <a:font script="Hang" typeface="맑은 고딕"/>
+        <a:font script="Hans" typeface="等线 Light"/>
+        <a:font script="Hant" typeface="新細明體"/>
+        <a:font script="Arab" typeface="Times New Roman"/>
+        <a:font script="Hebr" typeface="Times New Roman"/>
+        <a:font script="Thai" typeface="Angsana New"/>
+        <a:font script="Ethi" typeface="Nyala"/>
+        <a:font script="Beng" typeface="Vrinda"/>
+        <a:font script="Gujr" typeface="Shruti"/>
+        <a:font script="Khmr" typeface="MoolBoran"/>
+        <a:font script="Knda" typeface="Tunga"/>
+        <a:font script="Guru" typeface="Raavi"/>
+        <a:font script="Cans" typeface="Euphemia"/>
+        <a:font script="Cher" typeface="Plantagenet Cherokee"/>
+        <a:font script="Yiii" typeface="Microsoft Yi Baiti"/>
+        <a:font script="Tibt" typeface="Microsoft Himalaya"/>
+        <a:font script="Thaa" typeface="MV Boli"/>
+        <a:font script="Deva" typeface="Mangal"/>
+        <a:font script="Telu" typeface="Gautami"/>
+        <a:font script="Taml" typeface="Latha"/>
+        <a:font script="Syrc" typeface="Estrangelo Edessa"/>
+        <a:font script="Orya" typeface="Kalinga"/>
+        <a:font script="Mlym" typeface="Kartika"/>
+        <a:font script="Laoo" typeface="DokChampa"/>
+        <a:font script="Sinh" typeface="Iskoola Pota"/>
+        <a:font script="Mong" typeface="Mongolian Baiti"/>
+        <a:font script="Viet" typeface="Times New Roman"/>
+        <a:font script="Uigh" typeface="Microsoft Uighur"/>
+        <a:font script="Geor" typeface="Sylfaen"/>
+        <a:font script="Armn" typeface="Arial"/>
+        <a:font script="Bugi" typeface="Leelawadee UI"/>
+        <a:font script="Bopo" typeface="Microsoft JhengHei"/>
+        <a:font script="Java" typeface="Javanese Text"/>
+        <a:font script="Lisu" typeface="Segoe UI"/>
+        <a:font script="Mymr" typeface="Myanmar Text"/>
+        <a:font script="Nkoo" typeface="Ebrima"/>
+        <a:font script="Olck" typeface="Nirmala UI"/>
+        <a:font script="Osma" typeface="Ebrima"/>
+        <a:font script="Phag" typeface="Phagspa"/>
+        <a:font script="Syrn" typeface="Estrangelo Edessa"/>
+        <a:font script="Syrj" typeface="Estrangelo Edessa"/>
+        <a:font script="Syre" typeface="Estrangelo Edessa"/>
+        <a:font script="Sora" typeface="Nirmala UI"/>
+        <a:font script="Tale" typeface="Microsoft Tai Le"/>
+        <a:font script="Talu" typeface="Microsoft New Tai Lue"/>
+        <a:font script="Tfng" typeface="Ebrima"/>
+      </a:majorFont>
+      <a:minorFont>
+        <a:latin typeface="Aptos" panose="02110004020202020204"/>
+        <a:ea typeface=""/>
+        <a:cs typeface=""/>
+        <a:font script="Jpan" typeface="游ゴシック"/>
+        <a:font script="Hang" typeface="맑은 고딕"/>
+        <a:font script="Hans" typeface="等线"/>
+        <a:font script="Hant" typeface="新細明體"/>
+        <a:font script="Arab" typeface="Arial"/>
+        <a:font script="Hebr" typeface="Arial"/>
+        <a:font script="Thai" typeface="Cordia New"/>
+        <a:font script="Ethi" typeface="Nyala"/>
+        <a:font script="Beng" typeface="Vrinda"/>
+        <a:font script="Gujr" typeface="Shruti"/>
+        <a:font script="Khmr" typeface="DaunPenh"/>
+        <a:font script="Knda" typeface="Tunga"/>
+        <a:font script="Guru" typeface="Raavi"/>
+        <a:font script="Cans" typeface="Euphemia"/>
+        <a:font script="Cher" typeface="Plantagenet Cherokee"/>
+        <a:font script="Yiii" typeface="Microsoft Yi Baiti"/>
+        <a:font script="Tibt" typeface="Microsoft Himalaya"/>
+        <a:font script="Thaa" typeface="MV Boli"/>
+        <a:font script="Deva" typeface="Mangal"/>
+        <a:font script="Telu" typeface="Gautami"/>
+        <a:font script="Taml" typeface="Latha"/>
+        <a:font script="Syrc" typeface="Estrangelo Edessa"/>
+        <a:font script="Orya" typeface="Kalinga"/>
+        <a:font script="Mlym" typeface="Kartika"/>
+        <a:font script="Laoo" typeface="DokChampa"/>
+        <a:font script="Sinh" typeface="Iskoola Pota"/>
+        <a:font script="Mong" typeface="Mongolian Baiti"/>
+        <a:font script="Viet" typeface="Arial"/>
+        <a:font script="Uigh" typeface="Microsoft Uighur"/>
+        <a:font script="Geor" typeface="Sylfaen"/>
+        <a:font script="Armn" typeface="Arial"/>
+        <a:font script="Bugi" typeface="Leelawadee UI"/>
+        <a:font script="Bopo" typeface="Microsoft JhengHei"/>
+        <a:font script="Java" typeface="Javanese Text"/>
+        <a:font script="Lisu" typeface="Segoe UI"/>
+        <a:font script="Mymr" typeface="Myanmar Text"/>
+        <a:font script="Nkoo" typeface="Ebrima"/>
+        <a:font script="Olck" typeface="Nirmala UI"/>
+        <a:font script="Osma" typeface="Ebrima"/>
+        <a:font script="Phag" typeface="Phagspa"/>
+        <a:font script="Syrn" typeface="Estrangelo Edessa"/>
+        <a:font script="Syrj" typeface="Estrangelo Edessa"/>
+        <a:font script="Syre" typeface="Estrangelo Edessa"/>
+        <a:font script="Sora" typeface="Nirmala UI"/>
+        <a:font script="Tale" typeface="Microsoft Tai Le"/>
+        <a:font script="Talu" typeface="Microsoft New Tai Lue"/>
+        <a:font script="Tfng" typeface="Ebrima"/>
+      </a:minorFont>
+    </a:fontScheme>
+    <a:fmtScheme name="Office">
+      <a:fillStyleLst>
+        <a:solidFill>
+          <a:schemeClr val="phClr"/>
+        </a:solidFill>
+        <a:gradFill rotWithShape="1">
+          <a:gsLst>
+            <a:gs pos="0">
+              <a:schemeClr val="phClr">
+                <a:lumMod val="110000"/>
+                <a:satMod val="105000"/>
+                <a:tint val="67000"/>
+              </a:schemeClr>
+            </a:gs>
+            <a:gs pos="50000">
+              <a:schemeClr val="phClr">
+                <a:lumMod val="105000"/>
+                <a:satMod val="103000"/>
+                <a:tint val="73000"/>
+              </a:schemeClr>
+            </a:gs>
+            <a:gs pos="100000">
+              <a:schemeClr val="phClr">
+                <a:lumMod val="105000"/>
+                <a:satMod val="109000"/>
+                <a:tint val="81000"/>
+              </a:schemeClr>
+            </a:gs>
+          </a:gsLst>
+          <a:lin ang="5400000" scaled="0"/>
+        </a:gradFill>
+        <a:gradFill rotWithShape="1">
+          <a:gsLst>
+            <a:gs pos="0">
+              <a:schemeClr val="phClr">
+                <a:satMod val="103000"/>
+                <a:lumMod val="102000"/>
+                <a:tint val="94000"/>
+              </a:schemeClr>
+            </a:gs>
+            <a:gs pos="50000">
+              <a:schemeClr val="phClr">
+                <a:satMod val="110000"/>
+                <a:lumMod val="100000"/>
+                <a:shade val="100000"/>
+              </a:schemeClr>
+            </a:gs>
+            <a:gs pos="100000">
+              <a:schemeClr val="phClr">
+                <a:lumMod val="99000"/>
+                <a:satMod val="120000"/>
+                <a:shade val="78000"/>
+              </a:schemeClr>
+            </a:gs>
+          </a:gsLst>
+          <a:lin ang="5400000" scaled="0"/>
+        </a:gradFill>
+      </a:fillStyleLst>
+      <a:lnStyleLst>
+        <a:ln w="12700" cap="flat" cmpd="sng" algn="ctr">
+          <a:solidFill>
+            <a:schemeClr val="phClr"/>
+          </a:solidFill>
+          <a:prstDash val="solid"/>
+          <a:miter lim="800000"/>
+        </a:ln>
+        <a:ln w="19050" cap="flat" cmpd="sng" algn="ctr">
+          <a:solidFill>
+            <a:schemeClr val="phClr"/>
+          </a:solidFill>
+          <a:prstDash val="solid"/>
+          <a:miter lim="800000"/>
+        </a:ln>
+        <a:ln w="25400" cap="flat" cmpd="sng" algn="ctr">
+          <a:solidFill>
+            <a:schemeClr val="phClr"/>
+          </a:solidFill>
+          <a:prstDash val="solid"/>
+          <a:miter lim="800000"/>
+        </a:ln>
+      </a:lnStyleLst>
+      <a:effectStyleLst>
+        <a:effectStyle>
+          <a:effectLst/>
+        </a:effectStyle>
+        <a:effectStyle>
+          <a:effectLst/>
+        </a:effectStyle>
+        <a:effectStyle>
+          <a:effectLst>
+            <a:outerShdw blurRad="57150" dist="19050" dir="5400000" algn="ctr" rotWithShape="0">
+              <a:srgbClr val="000000">
+                <a:alpha val="63000"/>
+              </a:srgbClr>
+            </a:outerShdw>
+          </a:effectLst>
+        </a:effectStyle>
+      </a:effectStyleLst>
+      <a:bgFillStyleLst>
+        <a:solidFill>
+          <a:schemeClr val="phClr"/>
+        </a:solidFill>
+        <a:solidFill>
+          <a:schemeClr val="phClr">
+            <a:tint val="95000"/>
+            <a:satMod val="170000"/>
+          </a:schemeClr>
+        </a:solidFill>
+        <a:gradFill rotWithShape="1">
+          <a:gsLst>
+            <a:gs pos="0">
+              <a:schemeClr val="phClr">
+                <a:tint val="93000"/>
+                <a:satMod val="150000"/>
+                <a:shade val="98000"/>
+                <a:lumMod val="102000"/>
+              </a:schemeClr>
+            </a:gs>
+            <a:gs pos="50000">
+              <a:schemeClr val="phClr">
+                <a:tint val="98000"/>
+                <a:satMod val="130000"/>
+                <a:shade val="90000"/>
+                <a:lumMod val="103000"/>
+              </a:schemeClr>
+            </a:gs>
+            <a:gs pos="100000">
+              <a:schemeClr val="phClr">
+                <a:shade val="63000"/>
+                <a:satMod val="120000"/>
+              </a:schemeClr>
+            </a:gs>
+          </a:gsLst>
+          <a:lin ang="5400000" scaled="0"/>
+        </a:gradFill>
+      </a:bgFillStyleLst>
+    </a:fmtScheme>
+  </a:themeElements>
+  <a:objectDefaults>
+    <a:lnDef>
+      <a:spPr/>
+      <a:bodyPr/>
+      <a:lstStyle/>
+      <a:style>
+        <a:lnRef idx="2">
+          <a:schemeClr val="accent1"/>
+        </a:lnRef>
+        <a:fillRef idx="0">
+          <a:schemeClr val="accent1"/>
+        </a:fillRef>
+        <a:effectRef idx="1">
+          <a:schemeClr val="accent1"/>
+        </a:effectRef>
+        <a:fontRef idx="minor">
+          <a:schemeClr val="tx1"/>
+        </a:fontRef>
+      </a:style>
+    </a:lnDef>
+  </a:objectDefaults>
+  <a:extraClrSchemeLst/>
+  <a:extLst>
+    <a:ext uri="{05A4C25C-085E-4340-85A3-A5531E510DB2}">
+      <thm15:themeFamily xmlns:thm15="http://schemas.microsoft.com/office/thememl/2012/main" name="Office Theme" id="{2E142A2C-CD16-42D6-873A-C26D2A0506FA}" vid="{1BDDFF52-6CD6-40A5-AB3C-68EB2F1E4D0A}"/>
+    </a:ext>
+  </a:extLst>
+</a:theme>
 </file>
</xml_diff>